<commit_message>
Add BiMamba architecture diagram and comparison hyperparameters
</commit_message>
<xml_diff>
--- a/reports/20261015_progress/ctf_separation_progress_20261015.pptx
+++ b/reports/20261015_progress/ctf_separation_progress_20261015.pptx
@@ -7,6 +7,8 @@
   <p:sldIdLst>
     <p:sldId id="256" r:id="rId7"/>
     <p:sldId id="257" r:id="rId9"/>
+    <p:sldId id="263" r:id="rId15"/>
+    <p:sldId id="264" r:id="rId16"/>
     <p:sldId id="258" r:id="rId10"/>
     <p:sldId id="259" r:id="rId11"/>
     <p:sldId id="260" r:id="rId12"/>
@@ -1089,6 +1091,213 @@
           <a:p>
             <a:r>
               <a:t>https://linear.app/nitsu22/issue/DAI-61</a:t>
+            </a:r>
+          </a:p>
+        </p:txBody>
+      </p:sp>
+      <p:sp>
+        <p:nvSpPr>
+          <p:cNvPr id="4" name="Slide Number Placeholder 3"/>
+          <p:cNvSpPr>
+            <a:spLocks noGrp="1"/>
+          </p:cNvSpPr>
+          <p:nvPr>
+            <p:ph type="sldNum" idx="5" sz="quarter"/>
+          </p:nvPr>
+        </p:nvSpPr>
+        <p:spPr/>
+      </p:sp>
+    </p:spTree>
+  </p:cSld>
+  <p:clrMapOvr>
+    <a:masterClrMapping/>
+  </p:clrMapOvr>
+</p:notes>
+</file>
+
+<file path=ppt/notesSlides/notesSlide8.xml><?xml version="1.0" encoding="utf-8"?>
+<p:notes xmlns:a="http://schemas.openxmlformats.org/drawingml/2006/main" xmlns:p="http://schemas.openxmlformats.org/presentationml/2006/main" xmlns:r="http://schemas.openxmlformats.org/officeDocument/2006/relationships">
+  <p:cSld>
+    <p:spTree>
+      <p:nvGrpSpPr>
+        <p:cNvPr id="1" name=""/>
+        <p:cNvGrpSpPr/>
+        <p:nvPr/>
+      </p:nvGrpSpPr>
+      <p:grpSpPr>
+        <a:xfrm>
+          <a:off x="0" y="0"/>
+          <a:ext cx="0" cy="0"/>
+          <a:chOff x="0" y="0"/>
+          <a:chExt cx="0" cy="0"/>
+        </a:xfrm>
+      </p:grpSpPr>
+      <p:sp>
+        <p:nvSpPr>
+          <p:cNvPr id="2" name="Slide Image Placeholder 1"/>
+          <p:cNvSpPr>
+            <a:spLocks noGrp="1"/>
+          </p:cNvSpPr>
+          <p:nvPr>
+            <p:ph type="sldImg" idx="2"/>
+          </p:nvPr>
+        </p:nvSpPr>
+        <p:spPr/>
+      </p:sp>
+      <p:sp>
+        <p:nvSpPr>
+          <p:cNvPr id="3" name="Notes Placeholder 2"/>
+          <p:cNvSpPr>
+            <a:spLocks noGrp="1"/>
+          </p:cNvSpPr>
+          <p:nvPr>
+            <p:ph type="body" idx="3" sz="quarter"/>
+          </p:nvPr>
+        </p:nvSpPr>
+        <p:spPr/>
+        <p:txBody>
+          <a:bodyPr/>
+          <a:lstStyle/>
+          <a:p>
+            <a:r>
+              <a:t>元レポート：https://chatgpt.com/space/page_7274532747808191b5d98eaa8c387e2b</a:t>
+            </a:r>
+          </a:p>
+          <a:p/>
+          <a:p>
+            <a:r>
+              <a:t>基準モデルの実装に基づく。STFTは16kHz、FFT/window512、hop256、sqrthann、257周波数。実部・虚部をConv2D 2→64chへ入力。前段は時間BiMamba→軽量周波数ブロックを4段。時間BiMambaは各周波数で独立にLN→順方向Mambaと逆方向Mamba（入力時間反転後、出力を逆反転）→concat→Linear128→64→残差。Mamba d_state16/d_conv4/expand2。軽量周波数はdepthwise Conv幅5と低ランク全帯域MLP（bottleneck16/rank16）。時間Poolingは話者・周波数・チャネル別にsoftmax重みを学習し、2話者分の学習可能slot embeddingを加算。後段は周波数Attention4heads＋Conv-FFN128を2段、話者間で重み共有。headはLN→Linear64→128→SiLU→Linear128→120、real/imagを複素60tapに組み立て、出力[B,2,257,60]。通常Sweep PIMによる2秒RIR復元はCTF予測器の後段。</a:t>
+            </a:r>
+          </a:p>
+          <a:p>
+            <a:r>
+              <a:t>実装：</a:t>
+            </a:r>
+          </a:p>
+          <a:p>
+            <a:r>
+              <a:t>/net/midgar/work2/nitsu/learning/tf-locoformer/espnet/espnet2/rir/rec_rir/pooled_bimamba.py</a:t>
+            </a:r>
+          </a:p>
+          <a:p>
+            <a:r>
+              <a:t>/net/midgar/work2/nitsu/learning/tf-locoformer/espnet/espnet2/rir/rec_rir/model.py</a:t>
+            </a:r>
+          </a:p>
+          <a:p>
+            <a:r>
+              <a:t>/net/midgar/work2/nitsu/learning/tf-locoformer/espnet/egs2/whamr/rir_2spk/exp/frequency_module_code_20261012/espnet2/rir/rec_rir/pooled_bimamba.py</a:t>
+            </a:r>
+          </a:p>
+          <a:p>
+            <a:r>
+              <a:t>/net/midgar/work2/nitsu/learning/tf-locoformer/espnet/egs2/whamr/rir_2spk/exp/time_local_attention_code_20261012/espnet2/rir/rec_rir/pooled_bimamba.py</a:t>
+            </a:r>
+          </a:p>
+        </p:txBody>
+      </p:sp>
+      <p:sp>
+        <p:nvSpPr>
+          <p:cNvPr id="4" name="Slide Number Placeholder 3"/>
+          <p:cNvSpPr>
+            <a:spLocks noGrp="1"/>
+          </p:cNvSpPr>
+          <p:nvPr>
+            <p:ph type="sldNum" idx="5" sz="quarter"/>
+          </p:nvPr>
+        </p:nvSpPr>
+        <p:spPr/>
+      </p:sp>
+    </p:spTree>
+  </p:cSld>
+  <p:clrMapOvr>
+    <a:masterClrMapping/>
+  </p:clrMapOvr>
+</p:notes>
+</file>
+
+<file path=ppt/notesSlides/notesSlide9.xml><?xml version="1.0" encoding="utf-8"?>
+<p:notes xmlns:a="http://schemas.openxmlformats.org/drawingml/2006/main" xmlns:p="http://schemas.openxmlformats.org/presentationml/2006/main" xmlns:r="http://schemas.openxmlformats.org/officeDocument/2006/relationships">
+  <p:cSld>
+    <p:spTree>
+      <p:nvGrpSpPr>
+        <p:cNvPr id="1" name=""/>
+        <p:cNvGrpSpPr/>
+        <p:nvPr/>
+      </p:nvGrpSpPr>
+      <p:grpSpPr>
+        <a:xfrm>
+          <a:off x="0" y="0"/>
+          <a:ext cx="0" cy="0"/>
+          <a:chOff x="0" y="0"/>
+          <a:chExt cx="0" cy="0"/>
+        </a:xfrm>
+      </p:grpSpPr>
+      <p:sp>
+        <p:nvSpPr>
+          <p:cNvPr id="2" name="Slide Image Placeholder 1"/>
+          <p:cNvSpPr>
+            <a:spLocks noGrp="1"/>
+          </p:cNvSpPr>
+          <p:nvPr>
+            <p:ph type="sldImg" idx="2"/>
+          </p:nvPr>
+        </p:nvSpPr>
+        <p:spPr/>
+      </p:sp>
+      <p:sp>
+        <p:nvSpPr>
+          <p:cNvPr id="3" name="Notes Placeholder 2"/>
+          <p:cNvSpPr>
+            <a:spLocks noGrp="1"/>
+          </p:cNvSpPr>
+          <p:nvPr>
+            <p:ph type="body" idx="3" sz="quarter"/>
+          </p:nvPr>
+        </p:nvSpPr>
+        <p:spPr/>
+        <p:txBody>
+          <a:bodyPr/>
+          <a:lstStyle/>
+          <a:p>
+            <a:r>
+              <a:t>元レポート：https://chatgpt.com/space/page_7274532747808191b5d98eaa8c387e2b</a:t>
+            </a:r>
+          </a:p>
+          <a:p/>
+          <a:p>
+            <a:r>
+              <a:t>LS比較表の5構成に対応する設定。前段は時間＋周波数処理、後段はPooling後の周波数処理。周波数BiMambaのConv-FFNは比較用FrequencyAttentionBlockと共通。局所Attention125は各時間BiMamba直前へ挿入し、4heads・窓125frames（前後62、hop16msで±992ms）、時間RoPE。後続BiMambaは大域的なのでモデル全体が局所的とはしない。共通はFP32、4秒crop、train folded batch4、valid batch1、seed0、AdamW lr.001/eps1e-8/weight_decay0、grad_clip1、cosine warm restarts T0=5000/Tmult1/eta_min0、最大100epoch/patience10、SweepCTF v2 RIMag/PIT。2-blockは速度比較が記録した当該レシピのconfigを使用（学習元はTSUBAME）。</a:t>
+            </a:r>
+          </a:p>
+          <a:p>
+            <a:r>
+              <a:t>設定ファイル：</a:t>
+            </a:r>
+          </a:p>
+          <a:p>
+            <a:r>
+              <a:t>BiMamba 基準: /net/midgar/work2/nitsu/learning/tf-locoformer/espnet/egs2/whamr/rir_2spk/exp/rir_train_pooled_bimamba_2spk_nf_16k_sweep_v2/config.yaml</a:t>
+            </a:r>
+          </a:p>
+          <a:p>
+            <a:r>
+              <a:t>前段2＋後段2: /net/midgar/work2/nitsu/learning/tf-locoformer/espnet/egs2/whamr/rir_2spk/exp/frequency_module_code_20261012/egs2/whamr/rir_2spk/conf/tuning/train_pooled_bimamba_2spk_nf_16k_sweep_v2_2blocks.yaml</a:t>
+            </a:r>
+          </a:p>
+          <a:p>
+            <a:r>
+              <a:t>後段周波数BiMamba: /net/midgar/work2/nitsu/learning/tf-locoformer/espnet/egs2/whamr/rir_2spk/exp/rir_train_pooled_bimamba_2spk_nf_16k_sweep_v2_freq_post_bimamba/config.yaml</a:t>
+            </a:r>
+          </a:p>
+          <a:p>
+            <a:r>
+              <a:t>前後周波数BiMamba: /net/midgar/work2/nitsu/learning/tf-locoformer/espnet/egs2/whamr/rir_2spk/exp/rir_train_pooled_bimamba_2spk_nf_16k_sweep_v2_freq_both_bimamba/config.yaml</a:t>
+            </a:r>
+          </a:p>
+          <a:p>
+            <a:r>
+              <a:t>時間局所Attention125: /net/midgar/work2/nitsu/learning/tf-locoformer/espnet/egs2/whamr/rir_2spk/exp/rir_train_pooled_bimamba_2spk_nf_16k_sweep_v2_time_local_attention125/config.yaml</a:t>
             </a:r>
           </a:p>
         </p:txBody>
@@ -4414,7 +4623,7 @@
                 <a:latin typeface="Noto Sans CJK JP"/>
                 <a:ea typeface="Noto Sans CJK JP"/>
               </a:rPr>
-              <a:t>1 / 7</a:t>
+              <a:t>1 / 9</a:t>
             </a:r>
           </a:p>
         </p:txBody>
@@ -4941,7 +5150,7 @@
                 <a:latin typeface="Noto Sans CJK JP"/>
                 <a:ea typeface="Noto Sans CJK JP"/>
               </a:rPr>
-              <a:t>2 / 7</a:t>
+              <a:t>2 / 9</a:t>
             </a:r>
           </a:p>
         </p:txBody>
@@ -6422,7 +6631,7 @@
                 <a:latin typeface="Noto Sans CJK JP"/>
                 <a:ea typeface="Noto Sans CJK JP"/>
               </a:rPr>
-              <a:t>3 / 7</a:t>
+              <a:t>5 / 9</a:t>
             </a:r>
           </a:p>
         </p:txBody>
@@ -8411,7 +8620,7 @@
                 <a:latin typeface="Noto Sans CJK JP"/>
                 <a:ea typeface="Noto Sans CJK JP"/>
               </a:rPr>
-              <a:t>4 / 7</a:t>
+              <a:t>6 / 9</a:t>
             </a:r>
           </a:p>
         </p:txBody>
@@ -9384,7 +9593,7 @@
                 <a:latin typeface="Noto Sans CJK JP"/>
                 <a:ea typeface="Noto Sans CJK JP"/>
               </a:rPr>
-              <a:t>5 / 7</a:t>
+              <a:t>7 / 9</a:t>
             </a:r>
           </a:p>
         </p:txBody>
@@ -10230,7 +10439,7 @@
                 <a:latin typeface="Noto Sans CJK JP"/>
                 <a:ea typeface="Noto Sans CJK JP"/>
               </a:rPr>
-              <a:t>6 / 7</a:t>
+              <a:t>8 / 9</a:t>
             </a:r>
           </a:p>
         </p:txBody>
@@ -11543,7 +11752,7 @@
                 <a:latin typeface="Noto Sans CJK JP"/>
                 <a:ea typeface="Noto Sans CJK JP"/>
               </a:rPr>
-              <a:t>7 / 7</a:t>
+              <a:t>9 / 9</a:t>
             </a:r>
           </a:p>
         </p:txBody>
@@ -11820,6 +12029,3513 @@
                 <a:ea typeface="Noto Sans CJK JP"/>
               </a:rPr>
               <a:t>CTF再構成項と除残響構造の寄与を切り分ける。</a:t>
+            </a:r>
+          </a:p>
+        </p:txBody>
+      </p:sp>
+    </p:spTree>
+  </p:cSld>
+  <p:clrMapOvr>
+    <a:masterClrMapping/>
+  </p:clrMapOvr>
+</p:sld>
+</file>
+
+<file path=ppt/slides/slide8.xml><?xml version="1.0" encoding="utf-8"?>
+<p:sld xmlns:a="http://schemas.openxmlformats.org/drawingml/2006/main" xmlns:p="http://schemas.openxmlformats.org/presentationml/2006/main" xmlns:r="http://schemas.openxmlformats.org/officeDocument/2006/relationships">
+  <p:cSld>
+    <p:bg>
+      <p:bgPr>
+        <a:solidFill>
+          <a:srgbClr val="FFFFFF"/>
+        </a:solidFill>
+        <a:effectLst/>
+      </p:bgPr>
+    </p:bg>
+    <p:spTree>
+      <p:nvGrpSpPr>
+        <p:cNvPr id="1" name=""/>
+        <p:cNvGrpSpPr/>
+        <p:nvPr/>
+      </p:nvGrpSpPr>
+      <p:grpSpPr/>
+      <p:sp>
+        <p:nvSpPr>
+          <p:cNvPr id="2" name="TextBox 1"/>
+          <p:cNvSpPr txBox="1"/>
+          <p:nvPr/>
+        </p:nvSpPr>
+        <p:spPr>
+          <a:xfrm>
+            <a:off x="594360" y="438912"/>
+            <a:ext cx="10972800" cy="594360"/>
+          </a:xfrm>
+          <a:prstGeom prst="rect">
+            <a:avLst/>
+          </a:prstGeom>
+          <a:noFill/>
+        </p:spPr>
+        <p:txBody>
+          <a:bodyPr wrap="square" tIns="0" bIns="0" lIns="9144" rIns="9144">
+            <a:spAutoFit/>
+          </a:bodyPr>
+          <a:lstStyle/>
+          <a:p>
+            <a:pPr>
+              <a:lnSpc>
+                <a:spcPct val="110000"/>
+              </a:lnSpc>
+              <a:spcBef>
+                <a:spcPts val="0"/>
+              </a:spcBef>
+              <a:spcAft>
+                <a:spcPts val="400"/>
+              </a:spcAft>
+            </a:pPr>
+            <a:r>
+              <a:rPr sz="3000" b="1">
+                <a:solidFill>
+                  <a:srgbClr val="203C54"/>
+                </a:solidFill>
+                <a:latin typeface="Noto Sans CJK JP"/>
+                <a:ea typeface="Noto Sans CJK JP"/>
+              </a:rPr>
+              <a:t>BiMambaの基本構成</a:t>
+            </a:r>
+          </a:p>
+        </p:txBody>
+      </p:sp>
+      <p:sp>
+        <p:nvSpPr>
+          <p:cNvPr id="3" name="Rectangle 2"/>
+          <p:cNvSpPr/>
+          <p:nvPr/>
+        </p:nvSpPr>
+        <p:spPr>
+          <a:xfrm>
+            <a:off x="594360" y="1179576"/>
+            <a:ext cx="10972800" cy="10972"/>
+          </a:xfrm>
+          <a:prstGeom prst="rect">
+            <a:avLst/>
+          </a:prstGeom>
+          <a:solidFill>
+            <a:srgbClr val="BBBBBB"/>
+          </a:solidFill>
+          <a:ln>
+            <a:noFill/>
+          </a:ln>
+        </p:spPr>
+        <p:style>
+          <a:lnRef idx="1">
+            <a:schemeClr val="accent1"/>
+          </a:lnRef>
+          <a:fillRef idx="3">
+            <a:schemeClr val="accent1"/>
+          </a:fillRef>
+          <a:effectRef idx="2">
+            <a:schemeClr val="accent1"/>
+          </a:effectRef>
+          <a:fontRef idx="minor">
+            <a:schemeClr val="lt1"/>
+          </a:fontRef>
+        </p:style>
+        <p:txBody>
+          <a:bodyPr rtlCol="0" anchor="ctr"/>
+          <a:lstStyle/>
+          <a:p>
+            <a:pPr algn="ctr"/>
+          </a:p>
+        </p:txBody>
+      </p:sp>
+      <p:sp>
+        <p:nvSpPr>
+          <p:cNvPr id="4" name="TextBox 3"/>
+          <p:cNvSpPr txBox="1"/>
+          <p:nvPr/>
+        </p:nvSpPr>
+        <p:spPr>
+          <a:xfrm>
+            <a:off x="612648" y="1399032"/>
+            <a:ext cx="10881360" cy="512064"/>
+          </a:xfrm>
+          <a:prstGeom prst="rect">
+            <a:avLst/>
+          </a:prstGeom>
+          <a:noFill/>
+        </p:spPr>
+        <p:txBody>
+          <a:bodyPr wrap="square" tIns="0" bIns="0" lIns="9144" rIns="9144">
+            <a:spAutoFit/>
+          </a:bodyPr>
+          <a:lstStyle/>
+          <a:p>
+            <a:pPr>
+              <a:lnSpc>
+                <a:spcPct val="110000"/>
+              </a:lnSpc>
+              <a:spcBef>
+                <a:spcPts val="0"/>
+              </a:spcBef>
+              <a:spcAft>
+                <a:spcPts val="400"/>
+              </a:spcAft>
+            </a:pPr>
+            <a:r>
+              <a:rPr sz="1500" b="0">
+                <a:solidFill>
+                  <a:srgbClr val="666666"/>
+                </a:solidFill>
+                <a:latin typeface="Noto Sans CJK JP"/>
+                <a:ea typeface="Noto Sans CJK JP"/>
+              </a:rPr>
+              <a:t>基準モデル：前段4段・後段2段 / 特徴次元64 / 2話者・CTF 60 tap</a:t>
+            </a:r>
+          </a:p>
+        </p:txBody>
+      </p:sp>
+      <p:sp>
+        <p:nvSpPr>
+          <p:cNvPr id="5" name="Rectangle 4"/>
+          <p:cNvSpPr/>
+          <p:nvPr/>
+        </p:nvSpPr>
+        <p:spPr>
+          <a:xfrm>
+            <a:off x="594360" y="6281928"/>
+            <a:ext cx="10972800" cy="10972"/>
+          </a:xfrm>
+          <a:prstGeom prst="rect">
+            <a:avLst/>
+          </a:prstGeom>
+          <a:solidFill>
+            <a:srgbClr val="BBBBBB"/>
+          </a:solidFill>
+          <a:ln>
+            <a:noFill/>
+          </a:ln>
+        </p:spPr>
+        <p:style>
+          <a:lnRef idx="1">
+            <a:schemeClr val="accent1"/>
+          </a:lnRef>
+          <a:fillRef idx="3">
+            <a:schemeClr val="accent1"/>
+          </a:fillRef>
+          <a:effectRef idx="2">
+            <a:schemeClr val="accent1"/>
+          </a:effectRef>
+          <a:fontRef idx="minor">
+            <a:schemeClr val="lt1"/>
+          </a:fontRef>
+        </p:style>
+        <p:txBody>
+          <a:bodyPr rtlCol="0" anchor="ctr"/>
+          <a:lstStyle/>
+          <a:p>
+            <a:pPr algn="ctr"/>
+          </a:p>
+        </p:txBody>
+      </p:sp>
+      <p:sp>
+        <p:nvSpPr>
+          <p:cNvPr id="6" name="TextBox 5"/>
+          <p:cNvSpPr txBox="1"/>
+          <p:nvPr/>
+        </p:nvSpPr>
+        <p:spPr>
+          <a:xfrm>
+            <a:off x="612648" y="6428232"/>
+            <a:ext cx="9464040" cy="201168"/>
+          </a:xfrm>
+          <a:prstGeom prst="rect">
+            <a:avLst/>
+          </a:prstGeom>
+          <a:noFill/>
+        </p:spPr>
+        <p:txBody>
+          <a:bodyPr wrap="square" tIns="0" bIns="0" lIns="9144" rIns="9144">
+            <a:spAutoFit/>
+          </a:bodyPr>
+          <a:lstStyle/>
+          <a:p>
+            <a:pPr>
+              <a:lnSpc>
+                <a:spcPct val="110000"/>
+              </a:lnSpc>
+              <a:spcBef>
+                <a:spcPts val="0"/>
+              </a:spcBef>
+              <a:spcAft>
+                <a:spcPts val="400"/>
+              </a:spcAft>
+            </a:pPr>
+            <a:r>
+              <a:rPr sz="900" b="0">
+                <a:solidFill>
+                  <a:srgbClr val="666666"/>
+                </a:solidFill>
+                <a:latin typeface="Noto Sans CJK JP"/>
+                <a:ea typeface="Noto Sans CJK JP"/>
+              </a:rPr>
+              <a:t>出典：pooled_bimamba.py / 学習config</a:t>
+            </a:r>
+          </a:p>
+        </p:txBody>
+      </p:sp>
+      <p:sp>
+        <p:nvSpPr>
+          <p:cNvPr id="7" name="TextBox 6"/>
+          <p:cNvSpPr txBox="1"/>
+          <p:nvPr/>
+        </p:nvSpPr>
+        <p:spPr>
+          <a:xfrm>
+            <a:off x="9829800" y="6409944"/>
+            <a:ext cx="1033271" cy="228600"/>
+          </a:xfrm>
+          <a:prstGeom prst="rect">
+            <a:avLst/>
+          </a:prstGeom>
+          <a:noFill/>
+        </p:spPr>
+        <p:txBody>
+          <a:bodyPr wrap="square" tIns="0" bIns="0" lIns="9144" rIns="9144">
+            <a:spAutoFit/>
+          </a:bodyPr>
+          <a:lstStyle/>
+          <a:p>
+            <a:pPr>
+              <a:lnSpc>
+                <a:spcPct val="110000"/>
+              </a:lnSpc>
+              <a:spcBef>
+                <a:spcPts val="0"/>
+              </a:spcBef>
+              <a:spcAft>
+                <a:spcPts val="400"/>
+              </a:spcAft>
+            </a:pPr>
+            <a:r>
+              <a:rPr sz="1000" b="0">
+                <a:solidFill>
+                  <a:srgbClr val="203C54"/>
+                </a:solidFill>
+                <a:latin typeface="Noto Sans CJK JP"/>
+                <a:ea typeface="Noto Sans CJK JP"/>
+                <a:hlinkClick r:id="rId2"/>
+              </a:rPr>
+              <a:t>詳細レポート</a:t>
+            </a:r>
+          </a:p>
+        </p:txBody>
+      </p:sp>
+      <p:sp>
+        <p:nvSpPr>
+          <p:cNvPr id="8" name="TextBox 7"/>
+          <p:cNvSpPr txBox="1"/>
+          <p:nvPr/>
+        </p:nvSpPr>
+        <p:spPr>
+          <a:xfrm>
+            <a:off x="11045952" y="6419088"/>
+            <a:ext cx="502920" cy="228600"/>
+          </a:xfrm>
+          <a:prstGeom prst="rect">
+            <a:avLst/>
+          </a:prstGeom>
+          <a:noFill/>
+        </p:spPr>
+        <p:txBody>
+          <a:bodyPr wrap="square" tIns="0" bIns="0" lIns="9144" rIns="9144">
+            <a:spAutoFit/>
+          </a:bodyPr>
+          <a:lstStyle/>
+          <a:p>
+            <a:pPr algn="r">
+              <a:lnSpc>
+                <a:spcPct val="110000"/>
+              </a:lnSpc>
+              <a:spcBef>
+                <a:spcPts val="0"/>
+              </a:spcBef>
+              <a:spcAft>
+                <a:spcPts val="400"/>
+              </a:spcAft>
+            </a:pPr>
+            <a:r>
+              <a:rPr sz="1000" b="0">
+                <a:solidFill>
+                  <a:srgbClr val="666666"/>
+                </a:solidFill>
+                <a:latin typeface="Noto Sans CJK JP"/>
+                <a:ea typeface="Noto Sans CJK JP"/>
+              </a:rPr>
+              <a:t>3 / 9</a:t>
+            </a:r>
+          </a:p>
+        </p:txBody>
+      </p:sp>
+      <p:sp>
+        <p:nvSpPr>
+          <p:cNvPr id="9" name="Rectangle 8"/>
+          <p:cNvSpPr/>
+          <p:nvPr/>
+        </p:nvSpPr>
+        <p:spPr>
+          <a:xfrm>
+            <a:off x="594360" y="2423160"/>
+            <a:ext cx="1691640" cy="1298448"/>
+          </a:xfrm>
+          <a:prstGeom prst="rect">
+            <a:avLst/>
+          </a:prstGeom>
+          <a:solidFill>
+            <a:srgbClr val="FFFFFF"/>
+          </a:solidFill>
+          <a:ln w="10160">
+            <a:solidFill>
+              <a:srgbClr val="777777"/>
+            </a:solidFill>
+          </a:ln>
+        </p:spPr>
+        <p:style>
+          <a:lnRef idx="1">
+            <a:schemeClr val="accent1"/>
+          </a:lnRef>
+          <a:fillRef idx="3">
+            <a:schemeClr val="accent1"/>
+          </a:fillRef>
+          <a:effectRef idx="2">
+            <a:schemeClr val="accent1"/>
+          </a:effectRef>
+          <a:fontRef idx="minor">
+            <a:schemeClr val="lt1"/>
+          </a:fontRef>
+        </p:style>
+        <p:txBody>
+          <a:bodyPr rtlCol="0" anchor="ctr"/>
+          <a:lstStyle/>
+          <a:p>
+            <a:pPr algn="ctr"/>
+          </a:p>
+        </p:txBody>
+      </p:sp>
+      <p:sp>
+        <p:nvSpPr>
+          <p:cNvPr id="10" name="TextBox 9"/>
+          <p:cNvSpPr txBox="1"/>
+          <p:nvPr/>
+        </p:nvSpPr>
+        <p:spPr>
+          <a:xfrm>
+            <a:off x="658368" y="2651760"/>
+            <a:ext cx="1563624" cy="914400"/>
+          </a:xfrm>
+          <a:prstGeom prst="rect">
+            <a:avLst/>
+          </a:prstGeom>
+          <a:noFill/>
+        </p:spPr>
+        <p:txBody>
+          <a:bodyPr wrap="square" tIns="0" bIns="0" lIns="9144" rIns="9144">
+            <a:spAutoFit/>
+          </a:bodyPr>
+          <a:lstStyle/>
+          <a:p>
+            <a:pPr algn="ctr">
+              <a:lnSpc>
+                <a:spcPct val="110000"/>
+              </a:lnSpc>
+              <a:spcBef>
+                <a:spcPts val="0"/>
+              </a:spcBef>
+              <a:spcAft>
+                <a:spcPts val="400"/>
+              </a:spcAft>
+            </a:pPr>
+            <a:r>
+              <a:rPr sz="1450" b="0">
+                <a:solidFill>
+                  <a:srgbClr val="222222"/>
+                </a:solidFill>
+                <a:latin typeface="Noto Sans CJK JP"/>
+                <a:ea typeface="Noto Sans CJK JP"/>
+              </a:rPr>
+              <a:t>混合音→STFT</a:t>
+            </a:r>
+          </a:p>
+          <a:p>
+            <a:pPr algn="ctr">
+              <a:lnSpc>
+                <a:spcPct val="110000"/>
+              </a:lnSpc>
+              <a:spcBef>
+                <a:spcPts val="0"/>
+              </a:spcBef>
+              <a:spcAft>
+                <a:spcPts val="400"/>
+              </a:spcAft>
+            </a:pPr>
+            <a:r>
+              <a:rPr sz="1450" b="0">
+                <a:solidFill>
+                  <a:srgbClr val="222222"/>
+                </a:solidFill>
+                <a:latin typeface="Noto Sans CJK JP"/>
+                <a:ea typeface="Noto Sans CJK JP"/>
+              </a:rPr>
+              <a:t>Conv2D 3×3</a:t>
+            </a:r>
+          </a:p>
+          <a:p>
+            <a:pPr algn="ctr">
+              <a:lnSpc>
+                <a:spcPct val="110000"/>
+              </a:lnSpc>
+              <a:spcBef>
+                <a:spcPts val="0"/>
+              </a:spcBef>
+              <a:spcAft>
+                <a:spcPts val="400"/>
+              </a:spcAft>
+            </a:pPr>
+            <a:r>
+              <a:rPr sz="1450" b="0">
+                <a:solidFill>
+                  <a:srgbClr val="222222"/>
+                </a:solidFill>
+                <a:latin typeface="Noto Sans CJK JP"/>
+                <a:ea typeface="Noto Sans CJK JP"/>
+              </a:rPr>
+              <a:t>2→64 ch</a:t>
+            </a:r>
+          </a:p>
+        </p:txBody>
+      </p:sp>
+      <p:sp>
+        <p:nvSpPr>
+          <p:cNvPr id="11" name="Right Arrow 10"/>
+          <p:cNvSpPr/>
+          <p:nvPr/>
+        </p:nvSpPr>
+        <p:spPr>
+          <a:xfrm>
+            <a:off x="2304288" y="2990088"/>
+            <a:ext cx="109728" cy="137160"/>
+          </a:xfrm>
+          <a:prstGeom prst="rightArrow">
+            <a:avLst/>
+          </a:prstGeom>
+          <a:solidFill>
+            <a:srgbClr val="222222"/>
+          </a:solidFill>
+          <a:ln>
+            <a:noFill/>
+          </a:ln>
+        </p:spPr>
+        <p:style>
+          <a:lnRef idx="1">
+            <a:schemeClr val="accent1"/>
+          </a:lnRef>
+          <a:fillRef idx="3">
+            <a:schemeClr val="accent1"/>
+          </a:fillRef>
+          <a:effectRef idx="2">
+            <a:schemeClr val="accent1"/>
+          </a:effectRef>
+          <a:fontRef idx="minor">
+            <a:schemeClr val="lt1"/>
+          </a:fontRef>
+        </p:style>
+        <p:txBody>
+          <a:bodyPr rtlCol="0" anchor="ctr"/>
+          <a:lstStyle/>
+          <a:p>
+            <a:pPr algn="ctr"/>
+          </a:p>
+        </p:txBody>
+      </p:sp>
+      <p:sp>
+        <p:nvSpPr>
+          <p:cNvPr id="12" name="Rectangle 11"/>
+          <p:cNvSpPr/>
+          <p:nvPr/>
+        </p:nvSpPr>
+        <p:spPr>
+          <a:xfrm>
+            <a:off x="2432304" y="2423160"/>
+            <a:ext cx="2057400" cy="1298448"/>
+          </a:xfrm>
+          <a:prstGeom prst="rect">
+            <a:avLst/>
+          </a:prstGeom>
+          <a:solidFill>
+            <a:srgbClr val="FFFFFF"/>
+          </a:solidFill>
+          <a:ln w="10160">
+            <a:solidFill>
+              <a:srgbClr val="777777"/>
+            </a:solidFill>
+          </a:ln>
+        </p:spPr>
+        <p:style>
+          <a:lnRef idx="1">
+            <a:schemeClr val="accent1"/>
+          </a:lnRef>
+          <a:fillRef idx="3">
+            <a:schemeClr val="accent1"/>
+          </a:fillRef>
+          <a:effectRef idx="2">
+            <a:schemeClr val="accent1"/>
+          </a:effectRef>
+          <a:fontRef idx="minor">
+            <a:schemeClr val="lt1"/>
+          </a:fontRef>
+        </p:style>
+        <p:txBody>
+          <a:bodyPr rtlCol="0" anchor="ctr"/>
+          <a:lstStyle/>
+          <a:p>
+            <a:pPr algn="ctr"/>
+          </a:p>
+        </p:txBody>
+      </p:sp>
+      <p:sp>
+        <p:nvSpPr>
+          <p:cNvPr id="13" name="TextBox 12"/>
+          <p:cNvSpPr txBox="1"/>
+          <p:nvPr/>
+        </p:nvSpPr>
+        <p:spPr>
+          <a:xfrm>
+            <a:off x="2496312" y="2651760"/>
+            <a:ext cx="1929384" cy="914400"/>
+          </a:xfrm>
+          <a:prstGeom prst="rect">
+            <a:avLst/>
+          </a:prstGeom>
+          <a:noFill/>
+        </p:spPr>
+        <p:txBody>
+          <a:bodyPr wrap="square" tIns="0" bIns="0" lIns="9144" rIns="9144">
+            <a:spAutoFit/>
+          </a:bodyPr>
+          <a:lstStyle/>
+          <a:p>
+            <a:pPr algn="ctr">
+              <a:lnSpc>
+                <a:spcPct val="110000"/>
+              </a:lnSpc>
+              <a:spcBef>
+                <a:spcPts val="0"/>
+              </a:spcBef>
+              <a:spcAft>
+                <a:spcPts val="400"/>
+              </a:spcAft>
+            </a:pPr>
+            <a:r>
+              <a:rPr sz="1450" b="0">
+                <a:solidFill>
+                  <a:srgbClr val="222222"/>
+                </a:solidFill>
+                <a:latin typeface="Noto Sans CJK JP"/>
+                <a:ea typeface="Noto Sans CJK JP"/>
+              </a:rPr>
+              <a:t>時間BiMamba</a:t>
+            </a:r>
+          </a:p>
+          <a:p>
+            <a:pPr algn="ctr">
+              <a:lnSpc>
+                <a:spcPct val="110000"/>
+              </a:lnSpc>
+              <a:spcBef>
+                <a:spcPts val="0"/>
+              </a:spcBef>
+              <a:spcAft>
+                <a:spcPts val="400"/>
+              </a:spcAft>
+            </a:pPr>
+            <a:r>
+              <a:rPr sz="1450" b="0">
+                <a:solidFill>
+                  <a:srgbClr val="222222"/>
+                </a:solidFill>
+                <a:latin typeface="Noto Sans CJK JP"/>
+                <a:ea typeface="Noto Sans CJK JP"/>
+              </a:rPr>
+              <a:t>→軽量周波数</a:t>
+            </a:r>
+          </a:p>
+          <a:p>
+            <a:pPr algn="ctr">
+              <a:lnSpc>
+                <a:spcPct val="110000"/>
+              </a:lnSpc>
+              <a:spcBef>
+                <a:spcPts val="0"/>
+              </a:spcBef>
+              <a:spcAft>
+                <a:spcPts val="400"/>
+              </a:spcAft>
+            </a:pPr>
+            <a:r>
+              <a:rPr sz="1450" b="0">
+                <a:solidFill>
+                  <a:srgbClr val="222222"/>
+                </a:solidFill>
+                <a:latin typeface="Noto Sans CJK JP"/>
+                <a:ea typeface="Noto Sans CJK JP"/>
+              </a:rPr>
+              <a:t>×4</a:t>
+            </a:r>
+          </a:p>
+        </p:txBody>
+      </p:sp>
+      <p:sp>
+        <p:nvSpPr>
+          <p:cNvPr id="14" name="Right Arrow 13"/>
+          <p:cNvSpPr/>
+          <p:nvPr/>
+        </p:nvSpPr>
+        <p:spPr>
+          <a:xfrm>
+            <a:off x="4507992" y="2990088"/>
+            <a:ext cx="109728" cy="137160"/>
+          </a:xfrm>
+          <a:prstGeom prst="rightArrow">
+            <a:avLst/>
+          </a:prstGeom>
+          <a:solidFill>
+            <a:srgbClr val="222222"/>
+          </a:solidFill>
+          <a:ln>
+            <a:noFill/>
+          </a:ln>
+        </p:spPr>
+        <p:style>
+          <a:lnRef idx="1">
+            <a:schemeClr val="accent1"/>
+          </a:lnRef>
+          <a:fillRef idx="3">
+            <a:schemeClr val="accent1"/>
+          </a:fillRef>
+          <a:effectRef idx="2">
+            <a:schemeClr val="accent1"/>
+          </a:effectRef>
+          <a:fontRef idx="minor">
+            <a:schemeClr val="lt1"/>
+          </a:fontRef>
+        </p:style>
+        <p:txBody>
+          <a:bodyPr rtlCol="0" anchor="ctr"/>
+          <a:lstStyle/>
+          <a:p>
+            <a:pPr algn="ctr"/>
+          </a:p>
+        </p:txBody>
+      </p:sp>
+      <p:sp>
+        <p:nvSpPr>
+          <p:cNvPr id="15" name="Rectangle 14"/>
+          <p:cNvSpPr/>
+          <p:nvPr/>
+        </p:nvSpPr>
+        <p:spPr>
+          <a:xfrm>
+            <a:off x="4636008" y="2423160"/>
+            <a:ext cx="1645920" cy="1298448"/>
+          </a:xfrm>
+          <a:prstGeom prst="rect">
+            <a:avLst/>
+          </a:prstGeom>
+          <a:solidFill>
+            <a:srgbClr val="FFFFFF"/>
+          </a:solidFill>
+          <a:ln w="10160">
+            <a:solidFill>
+              <a:srgbClr val="777777"/>
+            </a:solidFill>
+          </a:ln>
+        </p:spPr>
+        <p:style>
+          <a:lnRef idx="1">
+            <a:schemeClr val="accent1"/>
+          </a:lnRef>
+          <a:fillRef idx="3">
+            <a:schemeClr val="accent1"/>
+          </a:fillRef>
+          <a:effectRef idx="2">
+            <a:schemeClr val="accent1"/>
+          </a:effectRef>
+          <a:fontRef idx="minor">
+            <a:schemeClr val="lt1"/>
+          </a:fontRef>
+        </p:style>
+        <p:txBody>
+          <a:bodyPr rtlCol="0" anchor="ctr"/>
+          <a:lstStyle/>
+          <a:p>
+            <a:pPr algn="ctr"/>
+          </a:p>
+        </p:txBody>
+      </p:sp>
+      <p:sp>
+        <p:nvSpPr>
+          <p:cNvPr id="16" name="TextBox 15"/>
+          <p:cNvSpPr txBox="1"/>
+          <p:nvPr/>
+        </p:nvSpPr>
+        <p:spPr>
+          <a:xfrm>
+            <a:off x="4700016" y="2651760"/>
+            <a:ext cx="1517904" cy="914400"/>
+          </a:xfrm>
+          <a:prstGeom prst="rect">
+            <a:avLst/>
+          </a:prstGeom>
+          <a:noFill/>
+        </p:spPr>
+        <p:txBody>
+          <a:bodyPr wrap="square" tIns="0" bIns="0" lIns="9144" rIns="9144">
+            <a:spAutoFit/>
+          </a:bodyPr>
+          <a:lstStyle/>
+          <a:p>
+            <a:pPr algn="ctr">
+              <a:lnSpc>
+                <a:spcPct val="110000"/>
+              </a:lnSpc>
+              <a:spcBef>
+                <a:spcPts val="0"/>
+              </a:spcBef>
+              <a:spcAft>
+                <a:spcPts val="400"/>
+              </a:spcAft>
+            </a:pPr>
+            <a:r>
+              <a:rPr sz="1450" b="0">
+                <a:solidFill>
+                  <a:srgbClr val="222222"/>
+                </a:solidFill>
+                <a:latin typeface="Noto Sans CJK JP"/>
+                <a:ea typeface="Noto Sans CJK JP"/>
+              </a:rPr>
+              <a:t>時間Pooling</a:t>
+            </a:r>
+          </a:p>
+          <a:p>
+            <a:pPr algn="ctr">
+              <a:lnSpc>
+                <a:spcPct val="110000"/>
+              </a:lnSpc>
+              <a:spcBef>
+                <a:spcPts val="0"/>
+              </a:spcBef>
+              <a:spcAft>
+                <a:spcPts val="400"/>
+              </a:spcAft>
+            </a:pPr>
+            <a:r>
+              <a:rPr sz="1450" b="0">
+                <a:solidFill>
+                  <a:srgbClr val="222222"/>
+                </a:solidFill>
+                <a:latin typeface="Noto Sans CJK JP"/>
+                <a:ea typeface="Noto Sans CJK JP"/>
+              </a:rPr>
+              <a:t>2話者に集約</a:t>
+            </a:r>
+          </a:p>
+        </p:txBody>
+      </p:sp>
+      <p:sp>
+        <p:nvSpPr>
+          <p:cNvPr id="17" name="Right Arrow 16"/>
+          <p:cNvSpPr/>
+          <p:nvPr/>
+        </p:nvSpPr>
+        <p:spPr>
+          <a:xfrm>
+            <a:off x="6300216" y="2990088"/>
+            <a:ext cx="109728" cy="137160"/>
+          </a:xfrm>
+          <a:prstGeom prst="rightArrow">
+            <a:avLst/>
+          </a:prstGeom>
+          <a:solidFill>
+            <a:srgbClr val="222222"/>
+          </a:solidFill>
+          <a:ln>
+            <a:noFill/>
+          </a:ln>
+        </p:spPr>
+        <p:style>
+          <a:lnRef idx="1">
+            <a:schemeClr val="accent1"/>
+          </a:lnRef>
+          <a:fillRef idx="3">
+            <a:schemeClr val="accent1"/>
+          </a:fillRef>
+          <a:effectRef idx="2">
+            <a:schemeClr val="accent1"/>
+          </a:effectRef>
+          <a:fontRef idx="minor">
+            <a:schemeClr val="lt1"/>
+          </a:fontRef>
+        </p:style>
+        <p:txBody>
+          <a:bodyPr rtlCol="0" anchor="ctr"/>
+          <a:lstStyle/>
+          <a:p>
+            <a:pPr algn="ctr"/>
+          </a:p>
+        </p:txBody>
+      </p:sp>
+      <p:sp>
+        <p:nvSpPr>
+          <p:cNvPr id="18" name="Rectangle 17"/>
+          <p:cNvSpPr/>
+          <p:nvPr/>
+        </p:nvSpPr>
+        <p:spPr>
+          <a:xfrm>
+            <a:off x="6428232" y="2423160"/>
+            <a:ext cx="1965960" cy="1298448"/>
+          </a:xfrm>
+          <a:prstGeom prst="rect">
+            <a:avLst/>
+          </a:prstGeom>
+          <a:solidFill>
+            <a:srgbClr val="FFFFFF"/>
+          </a:solidFill>
+          <a:ln w="10160">
+            <a:solidFill>
+              <a:srgbClr val="777777"/>
+            </a:solidFill>
+          </a:ln>
+        </p:spPr>
+        <p:style>
+          <a:lnRef idx="1">
+            <a:schemeClr val="accent1"/>
+          </a:lnRef>
+          <a:fillRef idx="3">
+            <a:schemeClr val="accent1"/>
+          </a:fillRef>
+          <a:effectRef idx="2">
+            <a:schemeClr val="accent1"/>
+          </a:effectRef>
+          <a:fontRef idx="minor">
+            <a:schemeClr val="lt1"/>
+          </a:fontRef>
+        </p:style>
+        <p:txBody>
+          <a:bodyPr rtlCol="0" anchor="ctr"/>
+          <a:lstStyle/>
+          <a:p>
+            <a:pPr algn="ctr"/>
+          </a:p>
+        </p:txBody>
+      </p:sp>
+      <p:sp>
+        <p:nvSpPr>
+          <p:cNvPr id="19" name="TextBox 18"/>
+          <p:cNvSpPr txBox="1"/>
+          <p:nvPr/>
+        </p:nvSpPr>
+        <p:spPr>
+          <a:xfrm>
+            <a:off x="6492240" y="2651760"/>
+            <a:ext cx="1837943" cy="914400"/>
+          </a:xfrm>
+          <a:prstGeom prst="rect">
+            <a:avLst/>
+          </a:prstGeom>
+          <a:noFill/>
+        </p:spPr>
+        <p:txBody>
+          <a:bodyPr wrap="square" tIns="0" bIns="0" lIns="9144" rIns="9144">
+            <a:spAutoFit/>
+          </a:bodyPr>
+          <a:lstStyle/>
+          <a:p>
+            <a:pPr algn="ctr">
+              <a:lnSpc>
+                <a:spcPct val="110000"/>
+              </a:lnSpc>
+              <a:spcBef>
+                <a:spcPts val="0"/>
+              </a:spcBef>
+              <a:spcAft>
+                <a:spcPts val="400"/>
+              </a:spcAft>
+            </a:pPr>
+            <a:r>
+              <a:rPr sz="1450" b="0">
+                <a:solidFill>
+                  <a:srgbClr val="222222"/>
+                </a:solidFill>
+                <a:latin typeface="Noto Sans CJK JP"/>
+                <a:ea typeface="Noto Sans CJK JP"/>
+              </a:rPr>
+              <a:t>周波数Attention</a:t>
+            </a:r>
+          </a:p>
+          <a:p>
+            <a:pPr algn="ctr">
+              <a:lnSpc>
+                <a:spcPct val="110000"/>
+              </a:lnSpc>
+              <a:spcBef>
+                <a:spcPts val="0"/>
+              </a:spcBef>
+              <a:spcAft>
+                <a:spcPts val="400"/>
+              </a:spcAft>
+            </a:pPr>
+            <a:r>
+              <a:rPr sz="1450" b="0">
+                <a:solidFill>
+                  <a:srgbClr val="222222"/>
+                </a:solidFill>
+                <a:latin typeface="Noto Sans CJK JP"/>
+                <a:ea typeface="Noto Sans CJK JP"/>
+              </a:rPr>
+              <a:t>＋Conv-FFN</a:t>
+            </a:r>
+          </a:p>
+          <a:p>
+            <a:pPr algn="ctr">
+              <a:lnSpc>
+                <a:spcPct val="110000"/>
+              </a:lnSpc>
+              <a:spcBef>
+                <a:spcPts val="0"/>
+              </a:spcBef>
+              <a:spcAft>
+                <a:spcPts val="400"/>
+              </a:spcAft>
+            </a:pPr>
+            <a:r>
+              <a:rPr sz="1450" b="0">
+                <a:solidFill>
+                  <a:srgbClr val="222222"/>
+                </a:solidFill>
+                <a:latin typeface="Noto Sans CJK JP"/>
+                <a:ea typeface="Noto Sans CJK JP"/>
+              </a:rPr>
+              <a:t>×2</a:t>
+            </a:r>
+          </a:p>
+        </p:txBody>
+      </p:sp>
+      <p:sp>
+        <p:nvSpPr>
+          <p:cNvPr id="20" name="Right Arrow 19"/>
+          <p:cNvSpPr/>
+          <p:nvPr/>
+        </p:nvSpPr>
+        <p:spPr>
+          <a:xfrm>
+            <a:off x="8412480" y="2990088"/>
+            <a:ext cx="109728" cy="137160"/>
+          </a:xfrm>
+          <a:prstGeom prst="rightArrow">
+            <a:avLst/>
+          </a:prstGeom>
+          <a:solidFill>
+            <a:srgbClr val="222222"/>
+          </a:solidFill>
+          <a:ln>
+            <a:noFill/>
+          </a:ln>
+        </p:spPr>
+        <p:style>
+          <a:lnRef idx="1">
+            <a:schemeClr val="accent1"/>
+          </a:lnRef>
+          <a:fillRef idx="3">
+            <a:schemeClr val="accent1"/>
+          </a:fillRef>
+          <a:effectRef idx="2">
+            <a:schemeClr val="accent1"/>
+          </a:effectRef>
+          <a:fontRef idx="minor">
+            <a:schemeClr val="lt1"/>
+          </a:fontRef>
+        </p:style>
+        <p:txBody>
+          <a:bodyPr rtlCol="0" anchor="ctr"/>
+          <a:lstStyle/>
+          <a:p>
+            <a:pPr algn="ctr"/>
+          </a:p>
+        </p:txBody>
+      </p:sp>
+      <p:sp>
+        <p:nvSpPr>
+          <p:cNvPr id="21" name="Rectangle 20"/>
+          <p:cNvSpPr/>
+          <p:nvPr/>
+        </p:nvSpPr>
+        <p:spPr>
+          <a:xfrm>
+            <a:off x="8540496" y="2423160"/>
+            <a:ext cx="1463040" cy="1298448"/>
+          </a:xfrm>
+          <a:prstGeom prst="rect">
+            <a:avLst/>
+          </a:prstGeom>
+          <a:solidFill>
+            <a:srgbClr val="FFFFFF"/>
+          </a:solidFill>
+          <a:ln w="10160">
+            <a:solidFill>
+              <a:srgbClr val="777777"/>
+            </a:solidFill>
+          </a:ln>
+        </p:spPr>
+        <p:style>
+          <a:lnRef idx="1">
+            <a:schemeClr val="accent1"/>
+          </a:lnRef>
+          <a:fillRef idx="3">
+            <a:schemeClr val="accent1"/>
+          </a:fillRef>
+          <a:effectRef idx="2">
+            <a:schemeClr val="accent1"/>
+          </a:effectRef>
+          <a:fontRef idx="minor">
+            <a:schemeClr val="lt1"/>
+          </a:fontRef>
+        </p:style>
+        <p:txBody>
+          <a:bodyPr rtlCol="0" anchor="ctr"/>
+          <a:lstStyle/>
+          <a:p>
+            <a:pPr algn="ctr"/>
+          </a:p>
+        </p:txBody>
+      </p:sp>
+      <p:sp>
+        <p:nvSpPr>
+          <p:cNvPr id="22" name="TextBox 21"/>
+          <p:cNvSpPr txBox="1"/>
+          <p:nvPr/>
+        </p:nvSpPr>
+        <p:spPr>
+          <a:xfrm>
+            <a:off x="8604504" y="2651760"/>
+            <a:ext cx="1335024" cy="914400"/>
+          </a:xfrm>
+          <a:prstGeom prst="rect">
+            <a:avLst/>
+          </a:prstGeom>
+          <a:noFill/>
+        </p:spPr>
+        <p:txBody>
+          <a:bodyPr wrap="square" tIns="0" bIns="0" lIns="9144" rIns="9144">
+            <a:spAutoFit/>
+          </a:bodyPr>
+          <a:lstStyle/>
+          <a:p>
+            <a:pPr algn="ctr">
+              <a:lnSpc>
+                <a:spcPct val="110000"/>
+              </a:lnSpc>
+              <a:spcBef>
+                <a:spcPts val="0"/>
+              </a:spcBef>
+              <a:spcAft>
+                <a:spcPts val="400"/>
+              </a:spcAft>
+            </a:pPr>
+            <a:r>
+              <a:rPr sz="1450" b="0">
+                <a:solidFill>
+                  <a:srgbClr val="222222"/>
+                </a:solidFill>
+                <a:latin typeface="Noto Sans CJK JP"/>
+                <a:ea typeface="Noto Sans CJK JP"/>
+              </a:rPr>
+              <a:t>共有MLP</a:t>
+            </a:r>
+          </a:p>
+          <a:p>
+            <a:pPr algn="ctr">
+              <a:lnSpc>
+                <a:spcPct val="110000"/>
+              </a:lnSpc>
+              <a:spcBef>
+                <a:spcPts val="0"/>
+              </a:spcBef>
+              <a:spcAft>
+                <a:spcPts val="400"/>
+              </a:spcAft>
+            </a:pPr>
+            <a:r>
+              <a:rPr sz="1450" b="0">
+                <a:solidFill>
+                  <a:srgbClr val="222222"/>
+                </a:solidFill>
+                <a:latin typeface="Noto Sans CJK JP"/>
+                <a:ea typeface="Noto Sans CJK JP"/>
+              </a:rPr>
+              <a:t>64→128→120</a:t>
+            </a:r>
+          </a:p>
+        </p:txBody>
+      </p:sp>
+      <p:sp>
+        <p:nvSpPr>
+          <p:cNvPr id="23" name="Right Arrow 22"/>
+          <p:cNvSpPr/>
+          <p:nvPr/>
+        </p:nvSpPr>
+        <p:spPr>
+          <a:xfrm>
+            <a:off x="10021824" y="2990088"/>
+            <a:ext cx="109728" cy="137160"/>
+          </a:xfrm>
+          <a:prstGeom prst="rightArrow">
+            <a:avLst/>
+          </a:prstGeom>
+          <a:solidFill>
+            <a:srgbClr val="222222"/>
+          </a:solidFill>
+          <a:ln>
+            <a:noFill/>
+          </a:ln>
+        </p:spPr>
+        <p:style>
+          <a:lnRef idx="1">
+            <a:schemeClr val="accent1"/>
+          </a:lnRef>
+          <a:fillRef idx="3">
+            <a:schemeClr val="accent1"/>
+          </a:fillRef>
+          <a:effectRef idx="2">
+            <a:schemeClr val="accent1"/>
+          </a:effectRef>
+          <a:fontRef idx="minor">
+            <a:schemeClr val="lt1"/>
+          </a:fontRef>
+        </p:style>
+        <p:txBody>
+          <a:bodyPr rtlCol="0" anchor="ctr"/>
+          <a:lstStyle/>
+          <a:p>
+            <a:pPr algn="ctr"/>
+          </a:p>
+        </p:txBody>
+      </p:sp>
+      <p:sp>
+        <p:nvSpPr>
+          <p:cNvPr id="24" name="Rectangle 23"/>
+          <p:cNvSpPr/>
+          <p:nvPr/>
+        </p:nvSpPr>
+        <p:spPr>
+          <a:xfrm>
+            <a:off x="10149840" y="2423160"/>
+            <a:ext cx="1417320" cy="1298448"/>
+          </a:xfrm>
+          <a:prstGeom prst="rect">
+            <a:avLst/>
+          </a:prstGeom>
+          <a:solidFill>
+            <a:srgbClr val="FFFFFF"/>
+          </a:solidFill>
+          <a:ln w="10160">
+            <a:solidFill>
+              <a:srgbClr val="777777"/>
+            </a:solidFill>
+          </a:ln>
+        </p:spPr>
+        <p:style>
+          <a:lnRef idx="1">
+            <a:schemeClr val="accent1"/>
+          </a:lnRef>
+          <a:fillRef idx="3">
+            <a:schemeClr val="accent1"/>
+          </a:fillRef>
+          <a:effectRef idx="2">
+            <a:schemeClr val="accent1"/>
+          </a:effectRef>
+          <a:fontRef idx="minor">
+            <a:schemeClr val="lt1"/>
+          </a:fontRef>
+        </p:style>
+        <p:txBody>
+          <a:bodyPr rtlCol="0" anchor="ctr"/>
+          <a:lstStyle/>
+          <a:p>
+            <a:pPr algn="ctr"/>
+          </a:p>
+        </p:txBody>
+      </p:sp>
+      <p:sp>
+        <p:nvSpPr>
+          <p:cNvPr id="25" name="TextBox 24"/>
+          <p:cNvSpPr txBox="1"/>
+          <p:nvPr/>
+        </p:nvSpPr>
+        <p:spPr>
+          <a:xfrm>
+            <a:off x="10213848" y="2651760"/>
+            <a:ext cx="1289304" cy="914400"/>
+          </a:xfrm>
+          <a:prstGeom prst="rect">
+            <a:avLst/>
+          </a:prstGeom>
+          <a:noFill/>
+        </p:spPr>
+        <p:txBody>
+          <a:bodyPr wrap="square" tIns="0" bIns="0" lIns="9144" rIns="9144">
+            <a:spAutoFit/>
+          </a:bodyPr>
+          <a:lstStyle/>
+          <a:p>
+            <a:pPr algn="ctr">
+              <a:lnSpc>
+                <a:spcPct val="110000"/>
+              </a:lnSpc>
+              <a:spcBef>
+                <a:spcPts val="0"/>
+              </a:spcBef>
+              <a:spcAft>
+                <a:spcPts val="400"/>
+              </a:spcAft>
+            </a:pPr>
+            <a:r>
+              <a:rPr sz="1450" b="0">
+                <a:solidFill>
+                  <a:srgbClr val="222222"/>
+                </a:solidFill>
+                <a:latin typeface="Noto Sans CJK JP"/>
+                <a:ea typeface="Noto Sans CJK JP"/>
+              </a:rPr>
+              <a:t>複素CTF</a:t>
+            </a:r>
+          </a:p>
+          <a:p>
+            <a:pPr algn="ctr">
+              <a:lnSpc>
+                <a:spcPct val="110000"/>
+              </a:lnSpc>
+              <a:spcBef>
+                <a:spcPts val="0"/>
+              </a:spcBef>
+              <a:spcAft>
+                <a:spcPts val="400"/>
+              </a:spcAft>
+            </a:pPr>
+            <a:r>
+              <a:rPr sz="1450" b="0">
+                <a:solidFill>
+                  <a:srgbClr val="222222"/>
+                </a:solidFill>
+                <a:latin typeface="Noto Sans CJK JP"/>
+                <a:ea typeface="Noto Sans CJK JP"/>
+              </a:rPr>
+              <a:t>2話者</a:t>
+            </a:r>
+          </a:p>
+          <a:p>
+            <a:pPr algn="ctr">
+              <a:lnSpc>
+                <a:spcPct val="110000"/>
+              </a:lnSpc>
+              <a:spcBef>
+                <a:spcPts val="0"/>
+              </a:spcBef>
+              <a:spcAft>
+                <a:spcPts val="400"/>
+              </a:spcAft>
+            </a:pPr>
+            <a:r>
+              <a:rPr sz="1450" b="0">
+                <a:solidFill>
+                  <a:srgbClr val="222222"/>
+                </a:solidFill>
+                <a:latin typeface="Noto Sans CJK JP"/>
+                <a:ea typeface="Noto Sans CJK JP"/>
+              </a:rPr>
+              <a:t>各60 tap</a:t>
+            </a:r>
+          </a:p>
+        </p:txBody>
+      </p:sp>
+      <p:sp>
+        <p:nvSpPr>
+          <p:cNvPr id="26" name="TextBox 25"/>
+          <p:cNvSpPr txBox="1"/>
+          <p:nvPr/>
+        </p:nvSpPr>
+        <p:spPr>
+          <a:xfrm>
+            <a:off x="731520" y="4224528"/>
+            <a:ext cx="10789920" cy="594360"/>
+          </a:xfrm>
+          <a:prstGeom prst="rect">
+            <a:avLst/>
+          </a:prstGeom>
+          <a:noFill/>
+        </p:spPr>
+        <p:txBody>
+          <a:bodyPr wrap="square" tIns="0" bIns="0" lIns="9144" rIns="9144">
+            <a:spAutoFit/>
+          </a:bodyPr>
+          <a:lstStyle/>
+          <a:p>
+            <a:pPr>
+              <a:lnSpc>
+                <a:spcPct val="110000"/>
+              </a:lnSpc>
+              <a:spcBef>
+                <a:spcPts val="0"/>
+              </a:spcBef>
+              <a:spcAft>
+                <a:spcPts val="400"/>
+              </a:spcAft>
+            </a:pPr>
+            <a:r>
+              <a:rPr sz="2000" b="0">
+                <a:solidFill>
+                  <a:srgbClr val="222222"/>
+                </a:solidFill>
+                <a:latin typeface="Noto Sans CJK JP"/>
+                <a:ea typeface="Noto Sans CJK JP"/>
+              </a:rPr>
+              <a:t>時間BiMamba：順方向・逆方向のMamba出力を結合し、線形射影と残差加算を行う。</a:t>
+            </a:r>
+          </a:p>
+        </p:txBody>
+      </p:sp>
+      <p:sp>
+        <p:nvSpPr>
+          <p:cNvPr id="27" name="TextBox 26"/>
+          <p:cNvSpPr txBox="1"/>
+          <p:nvPr/>
+        </p:nvSpPr>
+        <p:spPr>
+          <a:xfrm>
+            <a:off x="731520" y="4974336"/>
+            <a:ext cx="10789920" cy="457200"/>
+          </a:xfrm>
+          <a:prstGeom prst="rect">
+            <a:avLst/>
+          </a:prstGeom>
+          <a:noFill/>
+        </p:spPr>
+        <p:txBody>
+          <a:bodyPr wrap="square" tIns="0" bIns="0" lIns="9144" rIns="9144">
+            <a:spAutoFit/>
+          </a:bodyPr>
+          <a:lstStyle/>
+          <a:p>
+            <a:pPr>
+              <a:lnSpc>
+                <a:spcPct val="110000"/>
+              </a:lnSpc>
+              <a:spcBef>
+                <a:spcPts val="0"/>
+              </a:spcBef>
+              <a:spcAft>
+                <a:spcPts val="400"/>
+              </a:spcAft>
+            </a:pPr>
+            <a:r>
+              <a:rPr sz="2000" b="0">
+                <a:solidFill>
+                  <a:srgbClr val="222222"/>
+                </a:solidFill>
+                <a:latin typeface="Noto Sans CJK JP"/>
+                <a:ea typeface="Noto Sans CJK JP"/>
+              </a:rPr>
+              <a:t>時間Pooling：話者・周波数・チャネルごとの重みで、時間方向を集約する。</a:t>
+            </a:r>
+          </a:p>
+        </p:txBody>
+      </p:sp>
+      <p:sp>
+        <p:nvSpPr>
+          <p:cNvPr id="28" name="TextBox 27"/>
+          <p:cNvSpPr txBox="1"/>
+          <p:nvPr/>
+        </p:nvSpPr>
+        <p:spPr>
+          <a:xfrm>
+            <a:off x="731520" y="5669280"/>
+            <a:ext cx="10789920" cy="365760"/>
+          </a:xfrm>
+          <a:prstGeom prst="rect">
+            <a:avLst/>
+          </a:prstGeom>
+          <a:noFill/>
+        </p:spPr>
+        <p:txBody>
+          <a:bodyPr wrap="square" tIns="0" bIns="0" lIns="9144" rIns="9144">
+            <a:spAutoFit/>
+          </a:bodyPr>
+          <a:lstStyle/>
+          <a:p>
+            <a:pPr>
+              <a:lnSpc>
+                <a:spcPct val="110000"/>
+              </a:lnSpc>
+              <a:spcBef>
+                <a:spcPts val="0"/>
+              </a:spcBef>
+              <a:spcAft>
+                <a:spcPts val="400"/>
+              </a:spcAft>
+            </a:pPr>
+            <a:r>
+              <a:rPr sz="1900" b="0">
+                <a:solidFill>
+                  <a:srgbClr val="666666"/>
+                </a:solidFill>
+                <a:latin typeface="Noto Sans CJK JP"/>
+                <a:ea typeface="Noto Sans CJK JP"/>
+              </a:rPr>
+              <a:t>CTFから通常Sweep PIMで2秒のRIRを復元する。</a:t>
+            </a:r>
+          </a:p>
+        </p:txBody>
+      </p:sp>
+    </p:spTree>
+  </p:cSld>
+  <p:clrMapOvr>
+    <a:masterClrMapping/>
+  </p:clrMapOvr>
+</p:sld>
+</file>
+
+<file path=ppt/slides/slide9.xml><?xml version="1.0" encoding="utf-8"?>
+<p:sld xmlns:a="http://schemas.openxmlformats.org/drawingml/2006/main" xmlns:p="http://schemas.openxmlformats.org/presentationml/2006/main" xmlns:r="http://schemas.openxmlformats.org/officeDocument/2006/relationships">
+  <p:cSld>
+    <p:bg>
+      <p:bgPr>
+        <a:solidFill>
+          <a:srgbClr val="FFFFFF"/>
+        </a:solidFill>
+        <a:effectLst/>
+      </p:bgPr>
+    </p:bg>
+    <p:spTree>
+      <p:nvGrpSpPr>
+        <p:cNvPr id="1" name=""/>
+        <p:cNvGrpSpPr/>
+        <p:nvPr/>
+      </p:nvGrpSpPr>
+      <p:grpSpPr/>
+      <p:sp>
+        <p:nvSpPr>
+          <p:cNvPr id="2" name="TextBox 1"/>
+          <p:cNvSpPr txBox="1"/>
+          <p:nvPr/>
+        </p:nvSpPr>
+        <p:spPr>
+          <a:xfrm>
+            <a:off x="594360" y="438912"/>
+            <a:ext cx="10972800" cy="594360"/>
+          </a:xfrm>
+          <a:prstGeom prst="rect">
+            <a:avLst/>
+          </a:prstGeom>
+          <a:noFill/>
+        </p:spPr>
+        <p:txBody>
+          <a:bodyPr wrap="square" tIns="0" bIns="0" lIns="9144" rIns="9144">
+            <a:spAutoFit/>
+          </a:bodyPr>
+          <a:lstStyle/>
+          <a:p>
+            <a:pPr>
+              <a:lnSpc>
+                <a:spcPct val="110000"/>
+              </a:lnSpc>
+              <a:spcBef>
+                <a:spcPts val="0"/>
+              </a:spcBef>
+              <a:spcAft>
+                <a:spcPts val="400"/>
+              </a:spcAft>
+            </a:pPr>
+            <a:r>
+              <a:rPr sz="3000" b="1">
+                <a:solidFill>
+                  <a:srgbClr val="203C54"/>
+                </a:solidFill>
+                <a:latin typeface="Noto Sans CJK JP"/>
+                <a:ea typeface="Noto Sans CJK JP"/>
+              </a:rPr>
+              <a:t>BiMambaの比較構成とハイパーパラメータ</a:t>
+            </a:r>
+          </a:p>
+        </p:txBody>
+      </p:sp>
+      <p:sp>
+        <p:nvSpPr>
+          <p:cNvPr id="3" name="Rectangle 2"/>
+          <p:cNvSpPr/>
+          <p:nvPr/>
+        </p:nvSpPr>
+        <p:spPr>
+          <a:xfrm>
+            <a:off x="594360" y="1179576"/>
+            <a:ext cx="10972800" cy="10972"/>
+          </a:xfrm>
+          <a:prstGeom prst="rect">
+            <a:avLst/>
+          </a:prstGeom>
+          <a:solidFill>
+            <a:srgbClr val="BBBBBB"/>
+          </a:solidFill>
+          <a:ln>
+            <a:noFill/>
+          </a:ln>
+        </p:spPr>
+        <p:style>
+          <a:lnRef idx="1">
+            <a:schemeClr val="accent1"/>
+          </a:lnRef>
+          <a:fillRef idx="3">
+            <a:schemeClr val="accent1"/>
+          </a:fillRef>
+          <a:effectRef idx="2">
+            <a:schemeClr val="accent1"/>
+          </a:effectRef>
+          <a:fontRef idx="minor">
+            <a:schemeClr val="lt1"/>
+          </a:fontRef>
+        </p:style>
+        <p:txBody>
+          <a:bodyPr rtlCol="0" anchor="ctr"/>
+          <a:lstStyle/>
+          <a:p>
+            <a:pPr algn="ctr"/>
+          </a:p>
+        </p:txBody>
+      </p:sp>
+      <p:sp>
+        <p:nvSpPr>
+          <p:cNvPr id="4" name="TextBox 3"/>
+          <p:cNvSpPr txBox="1"/>
+          <p:nvPr/>
+        </p:nvSpPr>
+        <p:spPr>
+          <a:xfrm>
+            <a:off x="612648" y="1399032"/>
+            <a:ext cx="10881360" cy="512064"/>
+          </a:xfrm>
+          <a:prstGeom prst="rect">
+            <a:avLst/>
+          </a:prstGeom>
+          <a:noFill/>
+        </p:spPr>
+        <p:txBody>
+          <a:bodyPr wrap="square" tIns="0" bIns="0" lIns="9144" rIns="9144">
+            <a:spAutoFit/>
+          </a:bodyPr>
+          <a:lstStyle/>
+          <a:p>
+            <a:pPr>
+              <a:lnSpc>
+                <a:spcPct val="110000"/>
+              </a:lnSpc>
+              <a:spcBef>
+                <a:spcPts val="0"/>
+              </a:spcBef>
+              <a:spcAft>
+                <a:spcPts val="400"/>
+              </a:spcAft>
+            </a:pPr>
+            <a:r>
+              <a:rPr sz="1500" b="0">
+                <a:solidFill>
+                  <a:srgbClr val="666666"/>
+                </a:solidFill>
+                <a:latin typeface="Noto Sans CJK JP"/>
+                <a:ea typeface="Noto Sans CJK JP"/>
+              </a:rPr>
+              <a:t>前段：時間＋周波数処理 / 後段：時間Pooling後の周波数処理</a:t>
+            </a:r>
+          </a:p>
+        </p:txBody>
+      </p:sp>
+      <p:sp>
+        <p:nvSpPr>
+          <p:cNvPr id="5" name="Rectangle 4"/>
+          <p:cNvSpPr/>
+          <p:nvPr/>
+        </p:nvSpPr>
+        <p:spPr>
+          <a:xfrm>
+            <a:off x="594360" y="6281928"/>
+            <a:ext cx="10972800" cy="10972"/>
+          </a:xfrm>
+          <a:prstGeom prst="rect">
+            <a:avLst/>
+          </a:prstGeom>
+          <a:solidFill>
+            <a:srgbClr val="BBBBBB"/>
+          </a:solidFill>
+          <a:ln>
+            <a:noFill/>
+          </a:ln>
+        </p:spPr>
+        <p:style>
+          <a:lnRef idx="1">
+            <a:schemeClr val="accent1"/>
+          </a:lnRef>
+          <a:fillRef idx="3">
+            <a:schemeClr val="accent1"/>
+          </a:fillRef>
+          <a:effectRef idx="2">
+            <a:schemeClr val="accent1"/>
+          </a:effectRef>
+          <a:fontRef idx="minor">
+            <a:schemeClr val="lt1"/>
+          </a:fontRef>
+        </p:style>
+        <p:txBody>
+          <a:bodyPr rtlCol="0" anchor="ctr"/>
+          <a:lstStyle/>
+          <a:p>
+            <a:pPr algn="ctr"/>
+          </a:p>
+        </p:txBody>
+      </p:sp>
+      <p:sp>
+        <p:nvSpPr>
+          <p:cNvPr id="6" name="TextBox 5"/>
+          <p:cNvSpPr txBox="1"/>
+          <p:nvPr/>
+        </p:nvSpPr>
+        <p:spPr>
+          <a:xfrm>
+            <a:off x="612648" y="6428232"/>
+            <a:ext cx="9464040" cy="201168"/>
+          </a:xfrm>
+          <a:prstGeom prst="rect">
+            <a:avLst/>
+          </a:prstGeom>
+          <a:noFill/>
+        </p:spPr>
+        <p:txBody>
+          <a:bodyPr wrap="square" tIns="0" bIns="0" lIns="9144" rIns="9144">
+            <a:spAutoFit/>
+          </a:bodyPr>
+          <a:lstStyle/>
+          <a:p>
+            <a:pPr>
+              <a:lnSpc>
+                <a:spcPct val="110000"/>
+              </a:lnSpc>
+              <a:spcBef>
+                <a:spcPts val="0"/>
+              </a:spcBef>
+              <a:spcAft>
+                <a:spcPts val="400"/>
+              </a:spcAft>
+            </a:pPr>
+            <a:r>
+              <a:rPr sz="900" b="0">
+                <a:solidFill>
+                  <a:srgbClr val="666666"/>
+                </a:solidFill>
+                <a:latin typeface="Noto Sans CJK JP"/>
+                <a:ea typeface="Noto Sans CJK JP"/>
+              </a:rPr>
+              <a:t>出典：学習config / DAI-45 / DAI-49 / DAI-50 / DAI-54</a:t>
+            </a:r>
+          </a:p>
+        </p:txBody>
+      </p:sp>
+      <p:sp>
+        <p:nvSpPr>
+          <p:cNvPr id="7" name="TextBox 6"/>
+          <p:cNvSpPr txBox="1"/>
+          <p:nvPr/>
+        </p:nvSpPr>
+        <p:spPr>
+          <a:xfrm>
+            <a:off x="9829800" y="6409944"/>
+            <a:ext cx="1033271" cy="228600"/>
+          </a:xfrm>
+          <a:prstGeom prst="rect">
+            <a:avLst/>
+          </a:prstGeom>
+          <a:noFill/>
+        </p:spPr>
+        <p:txBody>
+          <a:bodyPr wrap="square" tIns="0" bIns="0" lIns="9144" rIns="9144">
+            <a:spAutoFit/>
+          </a:bodyPr>
+          <a:lstStyle/>
+          <a:p>
+            <a:pPr>
+              <a:lnSpc>
+                <a:spcPct val="110000"/>
+              </a:lnSpc>
+              <a:spcBef>
+                <a:spcPts val="0"/>
+              </a:spcBef>
+              <a:spcAft>
+                <a:spcPts val="400"/>
+              </a:spcAft>
+            </a:pPr>
+            <a:r>
+              <a:rPr sz="1000" b="0">
+                <a:solidFill>
+                  <a:srgbClr val="203C54"/>
+                </a:solidFill>
+                <a:latin typeface="Noto Sans CJK JP"/>
+                <a:ea typeface="Noto Sans CJK JP"/>
+                <a:hlinkClick r:id="rId2"/>
+              </a:rPr>
+              <a:t>詳細レポート</a:t>
+            </a:r>
+          </a:p>
+        </p:txBody>
+      </p:sp>
+      <p:sp>
+        <p:nvSpPr>
+          <p:cNvPr id="8" name="TextBox 7"/>
+          <p:cNvSpPr txBox="1"/>
+          <p:nvPr/>
+        </p:nvSpPr>
+        <p:spPr>
+          <a:xfrm>
+            <a:off x="11045952" y="6419088"/>
+            <a:ext cx="502920" cy="228600"/>
+          </a:xfrm>
+          <a:prstGeom prst="rect">
+            <a:avLst/>
+          </a:prstGeom>
+          <a:noFill/>
+        </p:spPr>
+        <p:txBody>
+          <a:bodyPr wrap="square" tIns="0" bIns="0" lIns="9144" rIns="9144">
+            <a:spAutoFit/>
+          </a:bodyPr>
+          <a:lstStyle/>
+          <a:p>
+            <a:pPr algn="r">
+              <a:lnSpc>
+                <a:spcPct val="110000"/>
+              </a:lnSpc>
+              <a:spcBef>
+                <a:spcPts val="0"/>
+              </a:spcBef>
+              <a:spcAft>
+                <a:spcPts val="400"/>
+              </a:spcAft>
+            </a:pPr>
+            <a:r>
+              <a:rPr sz="1000" b="0">
+                <a:solidFill>
+                  <a:srgbClr val="666666"/>
+                </a:solidFill>
+                <a:latin typeface="Noto Sans CJK JP"/>
+                <a:ea typeface="Noto Sans CJK JP"/>
+              </a:rPr>
+              <a:t>4 / 9</a:t>
+            </a:r>
+          </a:p>
+        </p:txBody>
+      </p:sp>
+      <p:graphicFrame>
+        <p:nvGraphicFramePr>
+          <p:cNvPr id="9" name="Table 8"/>
+          <p:cNvGraphicFramePr>
+            <a:graphicFrameLocks noGrp="1"/>
+          </p:cNvGraphicFramePr>
+          <p:nvPr/>
+        </p:nvGraphicFramePr>
+        <p:xfrm>
+          <a:off x="594360" y="1920240"/>
+          <a:ext cx="10972800" cy="3017520"/>
+        </p:xfrm>
+        <a:graphic>
+          <a:graphicData uri="http://schemas.openxmlformats.org/drawingml/2006/table">
+            <a:tbl>
+              <a:tblPr firstRow="1" bandRow="1">
+                <a:tableStyleId>{5C22544A-7EE6-4342-B048-85BDC9FD1C3A}</a:tableStyleId>
+              </a:tblPr>
+              <a:tblGrid>
+                <a:gridCol w="2743200"/>
+                <a:gridCol w="1005840"/>
+                <a:gridCol w="1737360"/>
+                <a:gridCol w="1737360"/>
+                <a:gridCol w="2286000"/>
+                <a:gridCol w="1463040"/>
+              </a:tblGrid>
+              <a:tr h="502920">
+                <a:tc>
+                  <a:txBody>
+                    <a:bodyPr/>
+                    <a:lstStyle/>
+                    <a:p>
+                      <a:pPr>
+                        <a:spcAft>
+                          <a:spcPts val="0"/>
+                        </a:spcAft>
+                      </a:pPr>
+                      <a:r>
+                        <a:rPr sz="1500" b="1">
+                          <a:solidFill>
+                            <a:srgbClr val="222222"/>
+                          </a:solidFill>
+                          <a:latin typeface="Noto Sans CJK JP"/>
+                          <a:ea typeface="Noto Sans CJK JP"/>
+                        </a:rPr>
+                        <a:t>構成</a:t>
+                      </a:r>
+                    </a:p>
+                  </a:txBody>
+                  <a:tcPr marL="73152" marR="73152" marT="27432" marB="27432" anchor="ctr">
+                    <a:solidFill>
+                      <a:srgbClr val="EEEEEE"/>
+                    </a:solidFill>
+                    <a:lnL>
+                      <a:noFill/>
+                    </a:lnL>
+                    <a:lnR>
+                      <a:noFill/>
+                    </a:lnR>
+                    <a:lnT>
+                      <a:noFill/>
+                    </a:lnT>
+                    <a:lnB w="6350">
+                      <a:solidFill>
+                        <a:srgbClr val="DDDDDD"/>
+                      </a:solidFill>
+                    </a:lnB>
+                  </a:tcPr>
+                </a:tc>
+                <a:tc>
+                  <a:txBody>
+                    <a:bodyPr/>
+                    <a:lstStyle/>
+                    <a:p>
+                      <a:pPr>
+                        <a:spcAft>
+                          <a:spcPts val="0"/>
+                        </a:spcAft>
+                      </a:pPr>
+                      <a:r>
+                        <a:rPr sz="1500" b="1">
+                          <a:solidFill>
+                            <a:srgbClr val="222222"/>
+                          </a:solidFill>
+                          <a:latin typeface="Noto Sans CJK JP"/>
+                          <a:ea typeface="Noto Sans CJK JP"/>
+                        </a:rPr>
+                        <a:t>前 / 後</a:t>
+                      </a:r>
+                    </a:p>
+                  </a:txBody>
+                  <a:tcPr marL="73152" marR="73152" marT="27432" marB="27432" anchor="ctr">
+                    <a:solidFill>
+                      <a:srgbClr val="EEEEEE"/>
+                    </a:solidFill>
+                    <a:lnL>
+                      <a:noFill/>
+                    </a:lnL>
+                    <a:lnR>
+                      <a:noFill/>
+                    </a:lnR>
+                    <a:lnT>
+                      <a:noFill/>
+                    </a:lnT>
+                    <a:lnB w="6350">
+                      <a:solidFill>
+                        <a:srgbClr val="DDDDDD"/>
+                      </a:solidFill>
+                    </a:lnB>
+                  </a:tcPr>
+                </a:tc>
+                <a:tc>
+                  <a:txBody>
+                    <a:bodyPr/>
+                    <a:lstStyle/>
+                    <a:p>
+                      <a:pPr>
+                        <a:spcAft>
+                          <a:spcPts val="0"/>
+                        </a:spcAft>
+                      </a:pPr>
+                      <a:r>
+                        <a:rPr sz="1500" b="1">
+                          <a:solidFill>
+                            <a:srgbClr val="222222"/>
+                          </a:solidFill>
+                          <a:latin typeface="Noto Sans CJK JP"/>
+                          <a:ea typeface="Noto Sans CJK JP"/>
+                        </a:rPr>
+                        <a:t>前段周波数</a:t>
+                      </a:r>
+                    </a:p>
+                  </a:txBody>
+                  <a:tcPr marL="73152" marR="73152" marT="27432" marB="27432" anchor="ctr">
+                    <a:solidFill>
+                      <a:srgbClr val="EEEEEE"/>
+                    </a:solidFill>
+                    <a:lnL>
+                      <a:noFill/>
+                    </a:lnL>
+                    <a:lnR>
+                      <a:noFill/>
+                    </a:lnR>
+                    <a:lnT>
+                      <a:noFill/>
+                    </a:lnT>
+                    <a:lnB w="6350">
+                      <a:solidFill>
+                        <a:srgbClr val="DDDDDD"/>
+                      </a:solidFill>
+                    </a:lnB>
+                  </a:tcPr>
+                </a:tc>
+                <a:tc>
+                  <a:txBody>
+                    <a:bodyPr/>
+                    <a:lstStyle/>
+                    <a:p>
+                      <a:pPr>
+                        <a:spcAft>
+                          <a:spcPts val="0"/>
+                        </a:spcAft>
+                      </a:pPr>
+                      <a:r>
+                        <a:rPr sz="1500" b="1">
+                          <a:solidFill>
+                            <a:srgbClr val="222222"/>
+                          </a:solidFill>
+                          <a:latin typeface="Noto Sans CJK JP"/>
+                          <a:ea typeface="Noto Sans CJK JP"/>
+                        </a:rPr>
+                        <a:t>後段周波数</a:t>
+                      </a:r>
+                    </a:p>
+                  </a:txBody>
+                  <a:tcPr marL="73152" marR="73152" marT="27432" marB="27432" anchor="ctr">
+                    <a:solidFill>
+                      <a:srgbClr val="EEEEEE"/>
+                    </a:solidFill>
+                    <a:lnL>
+                      <a:noFill/>
+                    </a:lnL>
+                    <a:lnR>
+                      <a:noFill/>
+                    </a:lnR>
+                    <a:lnT>
+                      <a:noFill/>
+                    </a:lnT>
+                    <a:lnB w="6350">
+                      <a:solidFill>
+                        <a:srgbClr val="DDDDDD"/>
+                      </a:solidFill>
+                    </a:lnB>
+                  </a:tcPr>
+                </a:tc>
+                <a:tc>
+                  <a:txBody>
+                    <a:bodyPr/>
+                    <a:lstStyle/>
+                    <a:p>
+                      <a:pPr>
+                        <a:spcAft>
+                          <a:spcPts val="0"/>
+                        </a:spcAft>
+                      </a:pPr>
+                      <a:r>
+                        <a:rPr sz="1500" b="1">
+                          <a:solidFill>
+                            <a:srgbClr val="222222"/>
+                          </a:solidFill>
+                          <a:latin typeface="Noto Sans CJK JP"/>
+                          <a:ea typeface="Noto Sans CJK JP"/>
+                        </a:rPr>
+                        <a:t>追加処理</a:t>
+                      </a:r>
+                    </a:p>
+                  </a:txBody>
+                  <a:tcPr marL="73152" marR="73152" marT="27432" marB="27432" anchor="ctr">
+                    <a:solidFill>
+                      <a:srgbClr val="EEEEEE"/>
+                    </a:solidFill>
+                    <a:lnL>
+                      <a:noFill/>
+                    </a:lnL>
+                    <a:lnR>
+                      <a:noFill/>
+                    </a:lnR>
+                    <a:lnT>
+                      <a:noFill/>
+                    </a:lnT>
+                    <a:lnB w="6350">
+                      <a:solidFill>
+                        <a:srgbClr val="DDDDDD"/>
+                      </a:solidFill>
+                    </a:lnB>
+                  </a:tcPr>
+                </a:tc>
+                <a:tc>
+                  <a:txBody>
+                    <a:bodyPr/>
+                    <a:lstStyle/>
+                    <a:p>
+                      <a:pPr algn="r">
+                        <a:spcAft>
+                          <a:spcPts val="0"/>
+                        </a:spcAft>
+                      </a:pPr>
+                      <a:r>
+                        <a:rPr sz="1500" b="1">
+                          <a:solidFill>
+                            <a:srgbClr val="222222"/>
+                          </a:solidFill>
+                          <a:latin typeface="Noto Sans CJK JP"/>
+                          <a:ea typeface="Noto Sans CJK JP"/>
+                        </a:rPr>
+                        <a:t>パラメータ</a:t>
+                      </a:r>
+                    </a:p>
+                  </a:txBody>
+                  <a:tcPr marL="73152" marR="73152" marT="27432" marB="27432" anchor="ctr">
+                    <a:solidFill>
+                      <a:srgbClr val="EEEEEE"/>
+                    </a:solidFill>
+                    <a:lnL>
+                      <a:noFill/>
+                    </a:lnL>
+                    <a:lnR>
+                      <a:noFill/>
+                    </a:lnR>
+                    <a:lnT>
+                      <a:noFill/>
+                    </a:lnT>
+                    <a:lnB w="6350">
+                      <a:solidFill>
+                        <a:srgbClr val="DDDDDD"/>
+                      </a:solidFill>
+                    </a:lnB>
+                  </a:tcPr>
+                </a:tc>
+              </a:tr>
+              <a:tr h="502920">
+                <a:tc>
+                  <a:txBody>
+                    <a:bodyPr/>
+                    <a:lstStyle/>
+                    <a:p>
+                      <a:pPr>
+                        <a:spcAft>
+                          <a:spcPts val="0"/>
+                        </a:spcAft>
+                      </a:pPr>
+                      <a:r>
+                        <a:rPr sz="1600" b="1">
+                          <a:solidFill>
+                            <a:srgbClr val="222222"/>
+                          </a:solidFill>
+                          <a:latin typeface="Noto Sans CJK JP"/>
+                          <a:ea typeface="Noto Sans CJK JP"/>
+                        </a:rPr>
+                        <a:t>BiMamba 基準</a:t>
+                      </a:r>
+                    </a:p>
+                  </a:txBody>
+                  <a:tcPr marL="73152" marR="73152" marT="27432" marB="27432" anchor="ctr">
+                    <a:solidFill>
+                      <a:srgbClr val="FFFFFF"/>
+                    </a:solidFill>
+                    <a:lnL>
+                      <a:noFill/>
+                    </a:lnL>
+                    <a:lnR>
+                      <a:noFill/>
+                    </a:lnR>
+                    <a:lnT>
+                      <a:noFill/>
+                    </a:lnT>
+                    <a:lnB w="6350">
+                      <a:solidFill>
+                        <a:srgbClr val="DDDDDD"/>
+                      </a:solidFill>
+                    </a:lnB>
+                  </a:tcPr>
+                </a:tc>
+                <a:tc>
+                  <a:txBody>
+                    <a:bodyPr/>
+                    <a:lstStyle/>
+                    <a:p>
+                      <a:pPr>
+                        <a:spcAft>
+                          <a:spcPts val="0"/>
+                        </a:spcAft>
+                      </a:pPr>
+                      <a:r>
+                        <a:rPr sz="1600" b="1">
+                          <a:solidFill>
+                            <a:srgbClr val="222222"/>
+                          </a:solidFill>
+                          <a:latin typeface="Noto Sans CJK JP"/>
+                          <a:ea typeface="Noto Sans CJK JP"/>
+                        </a:rPr>
+                        <a:t>4 / 2</a:t>
+                      </a:r>
+                    </a:p>
+                  </a:txBody>
+                  <a:tcPr marL="73152" marR="73152" marT="27432" marB="27432" anchor="ctr">
+                    <a:solidFill>
+                      <a:srgbClr val="FFFFFF"/>
+                    </a:solidFill>
+                    <a:lnL>
+                      <a:noFill/>
+                    </a:lnL>
+                    <a:lnR>
+                      <a:noFill/>
+                    </a:lnR>
+                    <a:lnT>
+                      <a:noFill/>
+                    </a:lnT>
+                    <a:lnB w="6350">
+                      <a:solidFill>
+                        <a:srgbClr val="DDDDDD"/>
+                      </a:solidFill>
+                    </a:lnB>
+                  </a:tcPr>
+                </a:tc>
+                <a:tc>
+                  <a:txBody>
+                    <a:bodyPr/>
+                    <a:lstStyle/>
+                    <a:p>
+                      <a:pPr>
+                        <a:spcAft>
+                          <a:spcPts val="0"/>
+                        </a:spcAft>
+                      </a:pPr>
+                      <a:r>
+                        <a:rPr sz="1600" b="1">
+                          <a:solidFill>
+                            <a:srgbClr val="222222"/>
+                          </a:solidFill>
+                          <a:latin typeface="Noto Sans CJK JP"/>
+                          <a:ea typeface="Noto Sans CJK JP"/>
+                        </a:rPr>
+                        <a:t>軽量</a:t>
+                      </a:r>
+                    </a:p>
+                  </a:txBody>
+                  <a:tcPr marL="73152" marR="73152" marT="27432" marB="27432" anchor="ctr">
+                    <a:solidFill>
+                      <a:srgbClr val="FFFFFF"/>
+                    </a:solidFill>
+                    <a:lnL>
+                      <a:noFill/>
+                    </a:lnL>
+                    <a:lnR>
+                      <a:noFill/>
+                    </a:lnR>
+                    <a:lnT>
+                      <a:noFill/>
+                    </a:lnT>
+                    <a:lnB w="6350">
+                      <a:solidFill>
+                        <a:srgbClr val="DDDDDD"/>
+                      </a:solidFill>
+                    </a:lnB>
+                  </a:tcPr>
+                </a:tc>
+                <a:tc>
+                  <a:txBody>
+                    <a:bodyPr/>
+                    <a:lstStyle/>
+                    <a:p>
+                      <a:pPr>
+                        <a:spcAft>
+                          <a:spcPts val="0"/>
+                        </a:spcAft>
+                      </a:pPr>
+                      <a:r>
+                        <a:rPr sz="1600" b="1">
+                          <a:solidFill>
+                            <a:srgbClr val="222222"/>
+                          </a:solidFill>
+                          <a:latin typeface="Noto Sans CJK JP"/>
+                          <a:ea typeface="Noto Sans CJK JP"/>
+                        </a:rPr>
+                        <a:t>Attention</a:t>
+                      </a:r>
+                    </a:p>
+                  </a:txBody>
+                  <a:tcPr marL="73152" marR="73152" marT="27432" marB="27432" anchor="ctr">
+                    <a:solidFill>
+                      <a:srgbClr val="FFFFFF"/>
+                    </a:solidFill>
+                    <a:lnL>
+                      <a:noFill/>
+                    </a:lnL>
+                    <a:lnR>
+                      <a:noFill/>
+                    </a:lnR>
+                    <a:lnT>
+                      <a:noFill/>
+                    </a:lnT>
+                    <a:lnB w="6350">
+                      <a:solidFill>
+                        <a:srgbClr val="DDDDDD"/>
+                      </a:solidFill>
+                    </a:lnB>
+                  </a:tcPr>
+                </a:tc>
+                <a:tc>
+                  <a:txBody>
+                    <a:bodyPr/>
+                    <a:lstStyle/>
+                    <a:p>
+                      <a:pPr>
+                        <a:spcAft>
+                          <a:spcPts val="0"/>
+                        </a:spcAft>
+                      </a:pPr>
+                      <a:r>
+                        <a:rPr sz="1600" b="1">
+                          <a:solidFill>
+                            <a:srgbClr val="222222"/>
+                          </a:solidFill>
+                          <a:latin typeface="Noto Sans CJK JP"/>
+                          <a:ea typeface="Noto Sans CJK JP"/>
+                        </a:rPr>
+                        <a:t>なし</a:t>
+                      </a:r>
+                    </a:p>
+                  </a:txBody>
+                  <a:tcPr marL="73152" marR="73152" marT="27432" marB="27432" anchor="ctr">
+                    <a:solidFill>
+                      <a:srgbClr val="FFFFFF"/>
+                    </a:solidFill>
+                    <a:lnL>
+                      <a:noFill/>
+                    </a:lnL>
+                    <a:lnR>
+                      <a:noFill/>
+                    </a:lnR>
+                    <a:lnT>
+                      <a:noFill/>
+                    </a:lnT>
+                    <a:lnB w="6350">
+                      <a:solidFill>
+                        <a:srgbClr val="DDDDDD"/>
+                      </a:solidFill>
+                    </a:lnB>
+                  </a:tcPr>
+                </a:tc>
+                <a:tc>
+                  <a:txBody>
+                    <a:bodyPr/>
+                    <a:lstStyle/>
+                    <a:p>
+                      <a:pPr algn="r">
+                        <a:spcAft>
+                          <a:spcPts val="0"/>
+                        </a:spcAft>
+                      </a:pPr>
+                      <a:r>
+                        <a:rPr sz="1600" b="1">
+                          <a:solidFill>
+                            <a:srgbClr val="222222"/>
+                          </a:solidFill>
+                          <a:latin typeface="Noto Sans CJK JP"/>
+                          <a:ea typeface="Noto Sans CJK JP"/>
+                        </a:rPr>
+                        <a:t>456,428</a:t>
+                      </a:r>
+                    </a:p>
+                  </a:txBody>
+                  <a:tcPr marL="73152" marR="73152" marT="27432" marB="27432" anchor="ctr">
+                    <a:solidFill>
+                      <a:srgbClr val="FFFFFF"/>
+                    </a:solidFill>
+                    <a:lnL>
+                      <a:noFill/>
+                    </a:lnL>
+                    <a:lnR>
+                      <a:noFill/>
+                    </a:lnR>
+                    <a:lnT>
+                      <a:noFill/>
+                    </a:lnT>
+                    <a:lnB w="6350">
+                      <a:solidFill>
+                        <a:srgbClr val="DDDDDD"/>
+                      </a:solidFill>
+                    </a:lnB>
+                  </a:tcPr>
+                </a:tc>
+              </a:tr>
+              <a:tr h="502920">
+                <a:tc>
+                  <a:txBody>
+                    <a:bodyPr/>
+                    <a:lstStyle/>
+                    <a:p>
+                      <a:pPr>
+                        <a:spcAft>
+                          <a:spcPts val="0"/>
+                        </a:spcAft>
+                      </a:pPr>
+                      <a:r>
+                        <a:rPr sz="1600" b="0">
+                          <a:solidFill>
+                            <a:srgbClr val="222222"/>
+                          </a:solidFill>
+                          <a:latin typeface="Noto Sans CJK JP"/>
+                          <a:ea typeface="Noto Sans CJK JP"/>
+                        </a:rPr>
+                        <a:t>前段2＋後段2</a:t>
+                      </a:r>
+                    </a:p>
+                  </a:txBody>
+                  <a:tcPr marL="73152" marR="73152" marT="27432" marB="27432" anchor="ctr">
+                    <a:solidFill>
+                      <a:srgbClr val="FFFFFF"/>
+                    </a:solidFill>
+                    <a:lnL>
+                      <a:noFill/>
+                    </a:lnL>
+                    <a:lnR>
+                      <a:noFill/>
+                    </a:lnR>
+                    <a:lnT>
+                      <a:noFill/>
+                    </a:lnT>
+                    <a:lnB w="6350">
+                      <a:solidFill>
+                        <a:srgbClr val="DDDDDD"/>
+                      </a:solidFill>
+                    </a:lnB>
+                  </a:tcPr>
+                </a:tc>
+                <a:tc>
+                  <a:txBody>
+                    <a:bodyPr/>
+                    <a:lstStyle/>
+                    <a:p>
+                      <a:pPr>
+                        <a:spcAft>
+                          <a:spcPts val="0"/>
+                        </a:spcAft>
+                      </a:pPr>
+                      <a:r>
+                        <a:rPr sz="1600" b="0">
+                          <a:solidFill>
+                            <a:srgbClr val="222222"/>
+                          </a:solidFill>
+                          <a:latin typeface="Noto Sans CJK JP"/>
+                          <a:ea typeface="Noto Sans CJK JP"/>
+                        </a:rPr>
+                        <a:t>2 / 2</a:t>
+                      </a:r>
+                    </a:p>
+                  </a:txBody>
+                  <a:tcPr marL="73152" marR="73152" marT="27432" marB="27432" anchor="ctr">
+                    <a:solidFill>
+                      <a:srgbClr val="FFFFFF"/>
+                    </a:solidFill>
+                    <a:lnL>
+                      <a:noFill/>
+                    </a:lnL>
+                    <a:lnR>
+                      <a:noFill/>
+                    </a:lnR>
+                    <a:lnT>
+                      <a:noFill/>
+                    </a:lnT>
+                    <a:lnB w="6350">
+                      <a:solidFill>
+                        <a:srgbClr val="DDDDDD"/>
+                      </a:solidFill>
+                    </a:lnB>
+                  </a:tcPr>
+                </a:tc>
+                <a:tc>
+                  <a:txBody>
+                    <a:bodyPr/>
+                    <a:lstStyle/>
+                    <a:p>
+                      <a:pPr>
+                        <a:spcAft>
+                          <a:spcPts val="0"/>
+                        </a:spcAft>
+                      </a:pPr>
+                      <a:r>
+                        <a:rPr sz="1600" b="0">
+                          <a:solidFill>
+                            <a:srgbClr val="222222"/>
+                          </a:solidFill>
+                          <a:latin typeface="Noto Sans CJK JP"/>
+                          <a:ea typeface="Noto Sans CJK JP"/>
+                        </a:rPr>
+                        <a:t>軽量</a:t>
+                      </a:r>
+                    </a:p>
+                  </a:txBody>
+                  <a:tcPr marL="73152" marR="73152" marT="27432" marB="27432" anchor="ctr">
+                    <a:solidFill>
+                      <a:srgbClr val="FFFFFF"/>
+                    </a:solidFill>
+                    <a:lnL>
+                      <a:noFill/>
+                    </a:lnL>
+                    <a:lnR>
+                      <a:noFill/>
+                    </a:lnR>
+                    <a:lnT>
+                      <a:noFill/>
+                    </a:lnT>
+                    <a:lnB w="6350">
+                      <a:solidFill>
+                        <a:srgbClr val="DDDDDD"/>
+                      </a:solidFill>
+                    </a:lnB>
+                  </a:tcPr>
+                </a:tc>
+                <a:tc>
+                  <a:txBody>
+                    <a:bodyPr/>
+                    <a:lstStyle/>
+                    <a:p>
+                      <a:pPr>
+                        <a:spcAft>
+                          <a:spcPts val="0"/>
+                        </a:spcAft>
+                      </a:pPr>
+                      <a:r>
+                        <a:rPr sz="1600" b="0">
+                          <a:solidFill>
+                            <a:srgbClr val="222222"/>
+                          </a:solidFill>
+                          <a:latin typeface="Noto Sans CJK JP"/>
+                          <a:ea typeface="Noto Sans CJK JP"/>
+                        </a:rPr>
+                        <a:t>Attention</a:t>
+                      </a:r>
+                    </a:p>
+                  </a:txBody>
+                  <a:tcPr marL="73152" marR="73152" marT="27432" marB="27432" anchor="ctr">
+                    <a:solidFill>
+                      <a:srgbClr val="FFFFFF"/>
+                    </a:solidFill>
+                    <a:lnL>
+                      <a:noFill/>
+                    </a:lnL>
+                    <a:lnR>
+                      <a:noFill/>
+                    </a:lnR>
+                    <a:lnT>
+                      <a:noFill/>
+                    </a:lnT>
+                    <a:lnB w="6350">
+                      <a:solidFill>
+                        <a:srgbClr val="DDDDDD"/>
+                      </a:solidFill>
+                    </a:lnB>
+                  </a:tcPr>
+                </a:tc>
+                <a:tc>
+                  <a:txBody>
+                    <a:bodyPr/>
+                    <a:lstStyle/>
+                    <a:p>
+                      <a:pPr>
+                        <a:spcAft>
+                          <a:spcPts val="0"/>
+                        </a:spcAft>
+                      </a:pPr>
+                      <a:r>
+                        <a:rPr sz="1600" b="0">
+                          <a:solidFill>
+                            <a:srgbClr val="222222"/>
+                          </a:solidFill>
+                          <a:latin typeface="Noto Sans CJK JP"/>
+                          <a:ea typeface="Noto Sans CJK JP"/>
+                        </a:rPr>
+                        <a:t>なし</a:t>
+                      </a:r>
+                    </a:p>
+                  </a:txBody>
+                  <a:tcPr marL="73152" marR="73152" marT="27432" marB="27432" anchor="ctr">
+                    <a:solidFill>
+                      <a:srgbClr val="FFFFFF"/>
+                    </a:solidFill>
+                    <a:lnL>
+                      <a:noFill/>
+                    </a:lnL>
+                    <a:lnR>
+                      <a:noFill/>
+                    </a:lnR>
+                    <a:lnT>
+                      <a:noFill/>
+                    </a:lnT>
+                    <a:lnB w="6350">
+                      <a:solidFill>
+                        <a:srgbClr val="DDDDDD"/>
+                      </a:solidFill>
+                    </a:lnB>
+                  </a:tcPr>
+                </a:tc>
+                <a:tc>
+                  <a:txBody>
+                    <a:bodyPr/>
+                    <a:lstStyle/>
+                    <a:p>
+                      <a:pPr algn="r">
+                        <a:spcAft>
+                          <a:spcPts val="0"/>
+                        </a:spcAft>
+                      </a:pPr>
+                      <a:r>
+                        <a:rPr sz="1600" b="0">
+                          <a:solidFill>
+                            <a:srgbClr val="222222"/>
+                          </a:solidFill>
+                          <a:latin typeface="Noto Sans CJK JP"/>
+                          <a:ea typeface="Noto Sans CJK JP"/>
+                        </a:rPr>
+                        <a:t>286,570</a:t>
+                      </a:r>
+                    </a:p>
+                  </a:txBody>
+                  <a:tcPr marL="73152" marR="73152" marT="27432" marB="27432" anchor="ctr">
+                    <a:solidFill>
+                      <a:srgbClr val="FFFFFF"/>
+                    </a:solidFill>
+                    <a:lnL>
+                      <a:noFill/>
+                    </a:lnL>
+                    <a:lnR>
+                      <a:noFill/>
+                    </a:lnR>
+                    <a:lnT>
+                      <a:noFill/>
+                    </a:lnT>
+                    <a:lnB w="6350">
+                      <a:solidFill>
+                        <a:srgbClr val="DDDDDD"/>
+                      </a:solidFill>
+                    </a:lnB>
+                  </a:tcPr>
+                </a:tc>
+              </a:tr>
+              <a:tr h="502920">
+                <a:tc>
+                  <a:txBody>
+                    <a:bodyPr/>
+                    <a:lstStyle/>
+                    <a:p>
+                      <a:pPr>
+                        <a:spcAft>
+                          <a:spcPts val="0"/>
+                        </a:spcAft>
+                      </a:pPr>
+                      <a:r>
+                        <a:rPr sz="1600" b="0">
+                          <a:solidFill>
+                            <a:srgbClr val="222222"/>
+                          </a:solidFill>
+                          <a:latin typeface="Noto Sans CJK JP"/>
+                          <a:ea typeface="Noto Sans CJK JP"/>
+                        </a:rPr>
+                        <a:t>後段周波数BiMamba</a:t>
+                      </a:r>
+                    </a:p>
+                  </a:txBody>
+                  <a:tcPr marL="73152" marR="73152" marT="27432" marB="27432" anchor="ctr">
+                    <a:solidFill>
+                      <a:srgbClr val="FFFFFF"/>
+                    </a:solidFill>
+                    <a:lnL>
+                      <a:noFill/>
+                    </a:lnL>
+                    <a:lnR>
+                      <a:noFill/>
+                    </a:lnR>
+                    <a:lnT>
+                      <a:noFill/>
+                    </a:lnT>
+                    <a:lnB w="6350">
+                      <a:solidFill>
+                        <a:srgbClr val="DDDDDD"/>
+                      </a:solidFill>
+                    </a:lnB>
+                  </a:tcPr>
+                </a:tc>
+                <a:tc>
+                  <a:txBody>
+                    <a:bodyPr/>
+                    <a:lstStyle/>
+                    <a:p>
+                      <a:pPr>
+                        <a:spcAft>
+                          <a:spcPts val="0"/>
+                        </a:spcAft>
+                      </a:pPr>
+                      <a:r>
+                        <a:rPr sz="1600" b="0">
+                          <a:solidFill>
+                            <a:srgbClr val="222222"/>
+                          </a:solidFill>
+                          <a:latin typeface="Noto Sans CJK JP"/>
+                          <a:ea typeface="Noto Sans CJK JP"/>
+                        </a:rPr>
+                        <a:t>4 / 2</a:t>
+                      </a:r>
+                    </a:p>
+                  </a:txBody>
+                  <a:tcPr marL="73152" marR="73152" marT="27432" marB="27432" anchor="ctr">
+                    <a:solidFill>
+                      <a:srgbClr val="FFFFFF"/>
+                    </a:solidFill>
+                    <a:lnL>
+                      <a:noFill/>
+                    </a:lnL>
+                    <a:lnR>
+                      <a:noFill/>
+                    </a:lnR>
+                    <a:lnT>
+                      <a:noFill/>
+                    </a:lnT>
+                    <a:lnB w="6350">
+                      <a:solidFill>
+                        <a:srgbClr val="DDDDDD"/>
+                      </a:solidFill>
+                    </a:lnB>
+                  </a:tcPr>
+                </a:tc>
+                <a:tc>
+                  <a:txBody>
+                    <a:bodyPr/>
+                    <a:lstStyle/>
+                    <a:p>
+                      <a:pPr>
+                        <a:spcAft>
+                          <a:spcPts val="0"/>
+                        </a:spcAft>
+                      </a:pPr>
+                      <a:r>
+                        <a:rPr sz="1600" b="0">
+                          <a:solidFill>
+                            <a:srgbClr val="222222"/>
+                          </a:solidFill>
+                          <a:latin typeface="Noto Sans CJK JP"/>
+                          <a:ea typeface="Noto Sans CJK JP"/>
+                        </a:rPr>
+                        <a:t>軽量</a:t>
+                      </a:r>
+                    </a:p>
+                  </a:txBody>
+                  <a:tcPr marL="73152" marR="73152" marT="27432" marB="27432" anchor="ctr">
+                    <a:solidFill>
+                      <a:srgbClr val="FFFFFF"/>
+                    </a:solidFill>
+                    <a:lnL>
+                      <a:noFill/>
+                    </a:lnL>
+                    <a:lnR>
+                      <a:noFill/>
+                    </a:lnR>
+                    <a:lnT>
+                      <a:noFill/>
+                    </a:lnT>
+                    <a:lnB w="6350">
+                      <a:solidFill>
+                        <a:srgbClr val="DDDDDD"/>
+                      </a:solidFill>
+                    </a:lnB>
+                  </a:tcPr>
+                </a:tc>
+                <a:tc>
+                  <a:txBody>
+                    <a:bodyPr/>
+                    <a:lstStyle/>
+                    <a:p>
+                      <a:pPr>
+                        <a:spcAft>
+                          <a:spcPts val="0"/>
+                        </a:spcAft>
+                      </a:pPr>
+                      <a:r>
+                        <a:rPr sz="1600" b="0">
+                          <a:solidFill>
+                            <a:srgbClr val="222222"/>
+                          </a:solidFill>
+                          <a:latin typeface="Noto Sans CJK JP"/>
+                          <a:ea typeface="Noto Sans CJK JP"/>
+                        </a:rPr>
+                        <a:t>BiMamba</a:t>
+                      </a:r>
+                    </a:p>
+                  </a:txBody>
+                  <a:tcPr marL="73152" marR="73152" marT="27432" marB="27432" anchor="ctr">
+                    <a:solidFill>
+                      <a:srgbClr val="FFFFFF"/>
+                    </a:solidFill>
+                    <a:lnL>
+                      <a:noFill/>
+                    </a:lnL>
+                    <a:lnR>
+                      <a:noFill/>
+                    </a:lnR>
+                    <a:lnT>
+                      <a:noFill/>
+                    </a:lnT>
+                    <a:lnB w="6350">
+                      <a:solidFill>
+                        <a:srgbClr val="DDDDDD"/>
+                      </a:solidFill>
+                    </a:lnB>
+                  </a:tcPr>
+                </a:tc>
+                <a:tc>
+                  <a:txBody>
+                    <a:bodyPr/>
+                    <a:lstStyle/>
+                    <a:p>
+                      <a:pPr>
+                        <a:spcAft>
+                          <a:spcPts val="0"/>
+                        </a:spcAft>
+                      </a:pPr>
+                      <a:r>
+                        <a:rPr sz="1600" b="0">
+                          <a:solidFill>
+                            <a:srgbClr val="222222"/>
+                          </a:solidFill>
+                          <a:latin typeface="Noto Sans CJK JP"/>
+                          <a:ea typeface="Noto Sans CJK JP"/>
+                        </a:rPr>
+                        <a:t>なし</a:t>
+                      </a:r>
+                    </a:p>
+                  </a:txBody>
+                  <a:tcPr marL="73152" marR="73152" marT="27432" marB="27432" anchor="ctr">
+                    <a:solidFill>
+                      <a:srgbClr val="FFFFFF"/>
+                    </a:solidFill>
+                    <a:lnL>
+                      <a:noFill/>
+                    </a:lnL>
+                    <a:lnR>
+                      <a:noFill/>
+                    </a:lnR>
+                    <a:lnT>
+                      <a:noFill/>
+                    </a:lnT>
+                    <a:lnB w="6350">
+                      <a:solidFill>
+                        <a:srgbClr val="DDDDDD"/>
+                      </a:solidFill>
+                    </a:lnB>
+                  </a:tcPr>
+                </a:tc>
+                <a:tc>
+                  <a:txBody>
+                    <a:bodyPr/>
+                    <a:lstStyle/>
+                    <a:p>
+                      <a:pPr algn="r">
+                        <a:spcAft>
+                          <a:spcPts val="0"/>
+                        </a:spcAft>
+                      </a:pPr>
+                      <a:r>
+                        <a:rPr sz="1600" b="0">
+                          <a:solidFill>
+                            <a:srgbClr val="222222"/>
+                          </a:solidFill>
+                          <a:latin typeface="Noto Sans CJK JP"/>
+                          <a:ea typeface="Noto Sans CJK JP"/>
+                        </a:rPr>
+                        <a:t>570,204</a:t>
+                      </a:r>
+                    </a:p>
+                  </a:txBody>
+                  <a:tcPr marL="73152" marR="73152" marT="27432" marB="27432" anchor="ctr">
+                    <a:solidFill>
+                      <a:srgbClr val="FFFFFF"/>
+                    </a:solidFill>
+                    <a:lnL>
+                      <a:noFill/>
+                    </a:lnL>
+                    <a:lnR>
+                      <a:noFill/>
+                    </a:lnR>
+                    <a:lnT>
+                      <a:noFill/>
+                    </a:lnT>
+                    <a:lnB w="6350">
+                      <a:solidFill>
+                        <a:srgbClr val="DDDDDD"/>
+                      </a:solidFill>
+                    </a:lnB>
+                  </a:tcPr>
+                </a:tc>
+              </a:tr>
+              <a:tr h="502920">
+                <a:tc>
+                  <a:txBody>
+                    <a:bodyPr/>
+                    <a:lstStyle/>
+                    <a:p>
+                      <a:pPr>
+                        <a:spcAft>
+                          <a:spcPts val="0"/>
+                        </a:spcAft>
+                      </a:pPr>
+                      <a:r>
+                        <a:rPr sz="1600" b="0">
+                          <a:solidFill>
+                            <a:srgbClr val="222222"/>
+                          </a:solidFill>
+                          <a:latin typeface="Noto Sans CJK JP"/>
+                          <a:ea typeface="Noto Sans CJK JP"/>
+                        </a:rPr>
+                        <a:t>前後周波数BiMamba</a:t>
+                      </a:r>
+                    </a:p>
+                  </a:txBody>
+                  <a:tcPr marL="73152" marR="73152" marT="27432" marB="27432" anchor="ctr">
+                    <a:solidFill>
+                      <a:srgbClr val="FFFFFF"/>
+                    </a:solidFill>
+                    <a:lnL>
+                      <a:noFill/>
+                    </a:lnL>
+                    <a:lnR>
+                      <a:noFill/>
+                    </a:lnR>
+                    <a:lnT>
+                      <a:noFill/>
+                    </a:lnT>
+                    <a:lnB w="6350">
+                      <a:solidFill>
+                        <a:srgbClr val="DDDDDD"/>
+                      </a:solidFill>
+                    </a:lnB>
+                  </a:tcPr>
+                </a:tc>
+                <a:tc>
+                  <a:txBody>
+                    <a:bodyPr/>
+                    <a:lstStyle/>
+                    <a:p>
+                      <a:pPr>
+                        <a:spcAft>
+                          <a:spcPts val="0"/>
+                        </a:spcAft>
+                      </a:pPr>
+                      <a:r>
+                        <a:rPr sz="1600" b="0">
+                          <a:solidFill>
+                            <a:srgbClr val="222222"/>
+                          </a:solidFill>
+                          <a:latin typeface="Noto Sans CJK JP"/>
+                          <a:ea typeface="Noto Sans CJK JP"/>
+                        </a:rPr>
+                        <a:t>4 / 2</a:t>
+                      </a:r>
+                    </a:p>
+                  </a:txBody>
+                  <a:tcPr marL="73152" marR="73152" marT="27432" marB="27432" anchor="ctr">
+                    <a:solidFill>
+                      <a:srgbClr val="FFFFFF"/>
+                    </a:solidFill>
+                    <a:lnL>
+                      <a:noFill/>
+                    </a:lnL>
+                    <a:lnR>
+                      <a:noFill/>
+                    </a:lnR>
+                    <a:lnT>
+                      <a:noFill/>
+                    </a:lnT>
+                    <a:lnB w="6350">
+                      <a:solidFill>
+                        <a:srgbClr val="DDDDDD"/>
+                      </a:solidFill>
+                    </a:lnB>
+                  </a:tcPr>
+                </a:tc>
+                <a:tc>
+                  <a:txBody>
+                    <a:bodyPr/>
+                    <a:lstStyle/>
+                    <a:p>
+                      <a:pPr>
+                        <a:spcAft>
+                          <a:spcPts val="0"/>
+                        </a:spcAft>
+                      </a:pPr>
+                      <a:r>
+                        <a:rPr sz="1600" b="0">
+                          <a:solidFill>
+                            <a:srgbClr val="222222"/>
+                          </a:solidFill>
+                          <a:latin typeface="Noto Sans CJK JP"/>
+                          <a:ea typeface="Noto Sans CJK JP"/>
+                        </a:rPr>
+                        <a:t>BiMamba</a:t>
+                      </a:r>
+                    </a:p>
+                  </a:txBody>
+                  <a:tcPr marL="73152" marR="73152" marT="27432" marB="27432" anchor="ctr">
+                    <a:solidFill>
+                      <a:srgbClr val="FFFFFF"/>
+                    </a:solidFill>
+                    <a:lnL>
+                      <a:noFill/>
+                    </a:lnL>
+                    <a:lnR>
+                      <a:noFill/>
+                    </a:lnR>
+                    <a:lnT>
+                      <a:noFill/>
+                    </a:lnT>
+                    <a:lnB w="6350">
+                      <a:solidFill>
+                        <a:srgbClr val="DDDDDD"/>
+                      </a:solidFill>
+                    </a:lnB>
+                  </a:tcPr>
+                </a:tc>
+                <a:tc>
+                  <a:txBody>
+                    <a:bodyPr/>
+                    <a:lstStyle/>
+                    <a:p>
+                      <a:pPr>
+                        <a:spcAft>
+                          <a:spcPts val="0"/>
+                        </a:spcAft>
+                      </a:pPr>
+                      <a:r>
+                        <a:rPr sz="1600" b="0">
+                          <a:solidFill>
+                            <a:srgbClr val="222222"/>
+                          </a:solidFill>
+                          <a:latin typeface="Noto Sans CJK JP"/>
+                          <a:ea typeface="Noto Sans CJK JP"/>
+                        </a:rPr>
+                        <a:t>BiMamba</a:t>
+                      </a:r>
+                    </a:p>
+                  </a:txBody>
+                  <a:tcPr marL="73152" marR="73152" marT="27432" marB="27432" anchor="ctr">
+                    <a:solidFill>
+                      <a:srgbClr val="FFFFFF"/>
+                    </a:solidFill>
+                    <a:lnL>
+                      <a:noFill/>
+                    </a:lnL>
+                    <a:lnR>
+                      <a:noFill/>
+                    </a:lnR>
+                    <a:lnT>
+                      <a:noFill/>
+                    </a:lnT>
+                    <a:lnB w="6350">
+                      <a:solidFill>
+                        <a:srgbClr val="DDDDDD"/>
+                      </a:solidFill>
+                    </a:lnB>
+                  </a:tcPr>
+                </a:tc>
+                <a:tc>
+                  <a:txBody>
+                    <a:bodyPr/>
+                    <a:lstStyle/>
+                    <a:p>
+                      <a:pPr>
+                        <a:spcAft>
+                          <a:spcPts val="0"/>
+                        </a:spcAft>
+                      </a:pPr>
+                      <a:r>
+                        <a:rPr sz="1600" b="0">
+                          <a:solidFill>
+                            <a:srgbClr val="222222"/>
+                          </a:solidFill>
+                          <a:latin typeface="Noto Sans CJK JP"/>
+                          <a:ea typeface="Noto Sans CJK JP"/>
+                        </a:rPr>
+                        <a:t>なし</a:t>
+                      </a:r>
+                    </a:p>
+                  </a:txBody>
+                  <a:tcPr marL="73152" marR="73152" marT="27432" marB="27432" anchor="ctr">
+                    <a:solidFill>
+                      <a:srgbClr val="FFFFFF"/>
+                    </a:solidFill>
+                    <a:lnL>
+                      <a:noFill/>
+                    </a:lnL>
+                    <a:lnR>
+                      <a:noFill/>
+                    </a:lnR>
+                    <a:lnT>
+                      <a:noFill/>
+                    </a:lnT>
+                    <a:lnB w="6350">
+                      <a:solidFill>
+                        <a:srgbClr val="DDDDDD"/>
+                      </a:solidFill>
+                    </a:lnB>
+                  </a:tcPr>
+                </a:tc>
+                <a:tc>
+                  <a:txBody>
+                    <a:bodyPr/>
+                    <a:lstStyle/>
+                    <a:p>
+                      <a:pPr algn="r">
+                        <a:spcAft>
+                          <a:spcPts val="0"/>
+                        </a:spcAft>
+                      </a:pPr>
+                      <a:r>
+                        <a:rPr sz="1600" b="0">
+                          <a:solidFill>
+                            <a:srgbClr val="222222"/>
+                          </a:solidFill>
+                          <a:latin typeface="Noto Sans CJK JP"/>
+                          <a:ea typeface="Noto Sans CJK JP"/>
+                        </a:rPr>
+                        <a:t>922,968</a:t>
+                      </a:r>
+                    </a:p>
+                  </a:txBody>
+                  <a:tcPr marL="73152" marR="73152" marT="27432" marB="27432" anchor="ctr">
+                    <a:solidFill>
+                      <a:srgbClr val="FFFFFF"/>
+                    </a:solidFill>
+                    <a:lnL>
+                      <a:noFill/>
+                    </a:lnL>
+                    <a:lnR>
+                      <a:noFill/>
+                    </a:lnR>
+                    <a:lnT>
+                      <a:noFill/>
+                    </a:lnT>
+                    <a:lnB w="6350">
+                      <a:solidFill>
+                        <a:srgbClr val="DDDDDD"/>
+                      </a:solidFill>
+                    </a:lnB>
+                  </a:tcPr>
+                </a:tc>
+              </a:tr>
+              <a:tr h="502920">
+                <a:tc>
+                  <a:txBody>
+                    <a:bodyPr/>
+                    <a:lstStyle/>
+                    <a:p>
+                      <a:pPr>
+                        <a:spcAft>
+                          <a:spcPts val="0"/>
+                        </a:spcAft>
+                      </a:pPr>
+                      <a:r>
+                        <a:rPr sz="1600" b="0">
+                          <a:solidFill>
+                            <a:srgbClr val="222222"/>
+                          </a:solidFill>
+                          <a:latin typeface="Noto Sans CJK JP"/>
+                          <a:ea typeface="Noto Sans CJK JP"/>
+                        </a:rPr>
+                        <a:t>時間局所Attention125</a:t>
+                      </a:r>
+                    </a:p>
+                  </a:txBody>
+                  <a:tcPr marL="73152" marR="73152" marT="27432" marB="27432" anchor="ctr">
+                    <a:solidFill>
+                      <a:srgbClr val="FFFFFF"/>
+                    </a:solidFill>
+                    <a:lnL>
+                      <a:noFill/>
+                    </a:lnL>
+                    <a:lnR>
+                      <a:noFill/>
+                    </a:lnR>
+                    <a:lnT>
+                      <a:noFill/>
+                    </a:lnT>
+                    <a:lnB w="6350">
+                      <a:solidFill>
+                        <a:srgbClr val="DDDDDD"/>
+                      </a:solidFill>
+                    </a:lnB>
+                  </a:tcPr>
+                </a:tc>
+                <a:tc>
+                  <a:txBody>
+                    <a:bodyPr/>
+                    <a:lstStyle/>
+                    <a:p>
+                      <a:pPr>
+                        <a:spcAft>
+                          <a:spcPts val="0"/>
+                        </a:spcAft>
+                      </a:pPr>
+                      <a:r>
+                        <a:rPr sz="1600" b="0">
+                          <a:solidFill>
+                            <a:srgbClr val="222222"/>
+                          </a:solidFill>
+                          <a:latin typeface="Noto Sans CJK JP"/>
+                          <a:ea typeface="Noto Sans CJK JP"/>
+                        </a:rPr>
+                        <a:t>4 / 2</a:t>
+                      </a:r>
+                    </a:p>
+                  </a:txBody>
+                  <a:tcPr marL="73152" marR="73152" marT="27432" marB="27432" anchor="ctr">
+                    <a:solidFill>
+                      <a:srgbClr val="FFFFFF"/>
+                    </a:solidFill>
+                    <a:lnL>
+                      <a:noFill/>
+                    </a:lnL>
+                    <a:lnR>
+                      <a:noFill/>
+                    </a:lnR>
+                    <a:lnT>
+                      <a:noFill/>
+                    </a:lnT>
+                    <a:lnB w="6350">
+                      <a:solidFill>
+                        <a:srgbClr val="DDDDDD"/>
+                      </a:solidFill>
+                    </a:lnB>
+                  </a:tcPr>
+                </a:tc>
+                <a:tc>
+                  <a:txBody>
+                    <a:bodyPr/>
+                    <a:lstStyle/>
+                    <a:p>
+                      <a:pPr>
+                        <a:spcAft>
+                          <a:spcPts val="0"/>
+                        </a:spcAft>
+                      </a:pPr>
+                      <a:r>
+                        <a:rPr sz="1600" b="0">
+                          <a:solidFill>
+                            <a:srgbClr val="222222"/>
+                          </a:solidFill>
+                          <a:latin typeface="Noto Sans CJK JP"/>
+                          <a:ea typeface="Noto Sans CJK JP"/>
+                        </a:rPr>
+                        <a:t>軽量</a:t>
+                      </a:r>
+                    </a:p>
+                  </a:txBody>
+                  <a:tcPr marL="73152" marR="73152" marT="27432" marB="27432" anchor="ctr">
+                    <a:solidFill>
+                      <a:srgbClr val="FFFFFF"/>
+                    </a:solidFill>
+                    <a:lnL>
+                      <a:noFill/>
+                    </a:lnL>
+                    <a:lnR>
+                      <a:noFill/>
+                    </a:lnR>
+                    <a:lnT>
+                      <a:noFill/>
+                    </a:lnT>
+                    <a:lnB w="6350">
+                      <a:solidFill>
+                        <a:srgbClr val="DDDDDD"/>
+                      </a:solidFill>
+                    </a:lnB>
+                  </a:tcPr>
+                </a:tc>
+                <a:tc>
+                  <a:txBody>
+                    <a:bodyPr/>
+                    <a:lstStyle/>
+                    <a:p>
+                      <a:pPr>
+                        <a:spcAft>
+                          <a:spcPts val="0"/>
+                        </a:spcAft>
+                      </a:pPr>
+                      <a:r>
+                        <a:rPr sz="1600" b="0">
+                          <a:solidFill>
+                            <a:srgbClr val="222222"/>
+                          </a:solidFill>
+                          <a:latin typeface="Noto Sans CJK JP"/>
+                          <a:ea typeface="Noto Sans CJK JP"/>
+                        </a:rPr>
+                        <a:t>Attention</a:t>
+                      </a:r>
+                    </a:p>
+                  </a:txBody>
+                  <a:tcPr marL="73152" marR="73152" marT="27432" marB="27432" anchor="ctr">
+                    <a:solidFill>
+                      <a:srgbClr val="FFFFFF"/>
+                    </a:solidFill>
+                    <a:lnL>
+                      <a:noFill/>
+                    </a:lnL>
+                    <a:lnR>
+                      <a:noFill/>
+                    </a:lnR>
+                    <a:lnT>
+                      <a:noFill/>
+                    </a:lnT>
+                    <a:lnB w="6350">
+                      <a:solidFill>
+                        <a:srgbClr val="DDDDDD"/>
+                      </a:solidFill>
+                    </a:lnB>
+                  </a:tcPr>
+                </a:tc>
+                <a:tc>
+                  <a:txBody>
+                    <a:bodyPr/>
+                    <a:lstStyle/>
+                    <a:p>
+                      <a:pPr>
+                        <a:spcAft>
+                          <a:spcPts val="0"/>
+                        </a:spcAft>
+                      </a:pPr>
+                      <a:r>
+                        <a:rPr sz="1600" b="0">
+                          <a:solidFill>
+                            <a:srgbClr val="222222"/>
+                          </a:solidFill>
+                          <a:latin typeface="Noto Sans CJK JP"/>
+                          <a:ea typeface="Noto Sans CJK JP"/>
+                        </a:rPr>
+                        <a:t>局所Attn 窓125</a:t>
+                      </a:r>
+                    </a:p>
+                  </a:txBody>
+                  <a:tcPr marL="73152" marR="73152" marT="27432" marB="27432" anchor="ctr">
+                    <a:solidFill>
+                      <a:srgbClr val="FFFFFF"/>
+                    </a:solidFill>
+                    <a:lnL>
+                      <a:noFill/>
+                    </a:lnL>
+                    <a:lnR>
+                      <a:noFill/>
+                    </a:lnR>
+                    <a:lnT>
+                      <a:noFill/>
+                    </a:lnT>
+                    <a:lnB w="6350">
+                      <a:solidFill>
+                        <a:srgbClr val="DDDDDD"/>
+                      </a:solidFill>
+                    </a:lnB>
+                  </a:tcPr>
+                </a:tc>
+                <a:tc>
+                  <a:txBody>
+                    <a:bodyPr/>
+                    <a:lstStyle/>
+                    <a:p>
+                      <a:pPr algn="r">
+                        <a:spcAft>
+                          <a:spcPts val="0"/>
+                        </a:spcAft>
+                      </a:pPr>
+                      <a:r>
+                        <a:rPr sz="1600" b="0">
+                          <a:solidFill>
+                            <a:srgbClr val="222222"/>
+                          </a:solidFill>
+                          <a:latin typeface="Noto Sans CJK JP"/>
+                          <a:ea typeface="Noto Sans CJK JP"/>
+                        </a:rPr>
+                        <a:t>523,500</a:t>
+                      </a:r>
+                    </a:p>
+                  </a:txBody>
+                  <a:tcPr marL="73152" marR="73152" marT="27432" marB="27432" anchor="ctr">
+                    <a:solidFill>
+                      <a:srgbClr val="FFFFFF"/>
+                    </a:solidFill>
+                    <a:lnL>
+                      <a:noFill/>
+                    </a:lnL>
+                    <a:lnR>
+                      <a:noFill/>
+                    </a:lnR>
+                    <a:lnT>
+                      <a:noFill/>
+                    </a:lnT>
+                    <a:lnB w="6350">
+                      <a:solidFill>
+                        <a:srgbClr val="DDDDDD"/>
+                      </a:solidFill>
+                    </a:lnB>
+                  </a:tcPr>
+                </a:tc>
+              </a:tr>
+            </a:tbl>
+          </a:graphicData>
+        </a:graphic>
+      </p:graphicFrame>
+      <p:sp>
+        <p:nvSpPr>
+          <p:cNvPr id="10" name="TextBox 9"/>
+          <p:cNvSpPr txBox="1"/>
+          <p:nvPr/>
+        </p:nvSpPr>
+        <p:spPr>
+          <a:xfrm>
+            <a:off x="731520" y="5111496"/>
+            <a:ext cx="10789920" cy="274320"/>
+          </a:xfrm>
+          <a:prstGeom prst="rect">
+            <a:avLst/>
+          </a:prstGeom>
+          <a:noFill/>
+        </p:spPr>
+        <p:txBody>
+          <a:bodyPr wrap="square" tIns="0" bIns="0" lIns="9144" rIns="9144">
+            <a:spAutoFit/>
+          </a:bodyPr>
+          <a:lstStyle/>
+          <a:p>
+            <a:pPr>
+              <a:lnSpc>
+                <a:spcPct val="110000"/>
+              </a:lnSpc>
+              <a:spcBef>
+                <a:spcPts val="0"/>
+              </a:spcBef>
+              <a:spcAft>
+                <a:spcPts val="400"/>
+              </a:spcAft>
+            </a:pPr>
+            <a:r>
+              <a:rPr sz="1600" b="0">
+                <a:solidFill>
+                  <a:srgbClr val="222222"/>
+                </a:solidFill>
+                <a:latin typeface="Noto Sans CJK JP"/>
+                <a:ea typeface="Noto Sans CJK JP"/>
+              </a:rPr>
+              <a:t>共通：D=64 / Mamba state=16・conv=4・expand=2 / Attention 4 heads / FFN=128</a:t>
+            </a:r>
+          </a:p>
+        </p:txBody>
+      </p:sp>
+      <p:sp>
+        <p:nvSpPr>
+          <p:cNvPr id="11" name="TextBox 10"/>
+          <p:cNvSpPr txBox="1"/>
+          <p:nvPr/>
+        </p:nvSpPr>
+        <p:spPr>
+          <a:xfrm>
+            <a:off x="731520" y="5504688"/>
+            <a:ext cx="10789920" cy="274320"/>
+          </a:xfrm>
+          <a:prstGeom prst="rect">
+            <a:avLst/>
+          </a:prstGeom>
+          <a:noFill/>
+        </p:spPr>
+        <p:txBody>
+          <a:bodyPr wrap="square" tIns="0" bIns="0" lIns="9144" rIns="9144">
+            <a:spAutoFit/>
+          </a:bodyPr>
+          <a:lstStyle/>
+          <a:p>
+            <a:pPr>
+              <a:lnSpc>
+                <a:spcPct val="110000"/>
+              </a:lnSpc>
+              <a:spcBef>
+                <a:spcPts val="0"/>
+              </a:spcBef>
+              <a:spcAft>
+                <a:spcPts val="400"/>
+              </a:spcAft>
+            </a:pPr>
+            <a:r>
+              <a:rPr sz="1600" b="0">
+                <a:solidFill>
+                  <a:srgbClr val="222222"/>
+                </a:solidFill>
+                <a:latin typeface="Noto Sans CJK JP"/>
+                <a:ea typeface="Noto Sans CJK JP"/>
+              </a:rPr>
+              <a:t>軽量周波数：kernel=5・bottleneck=16・rank=16 / Pooling隠れ32 / 出力MLP隠れ128</a:t>
+            </a:r>
+          </a:p>
+        </p:txBody>
+      </p:sp>
+      <p:sp>
+        <p:nvSpPr>
+          <p:cNvPr id="12" name="TextBox 11"/>
+          <p:cNvSpPr txBox="1"/>
+          <p:nvPr/>
+        </p:nvSpPr>
+        <p:spPr>
+          <a:xfrm>
+            <a:off x="731520" y="5897880"/>
+            <a:ext cx="10789920" cy="274320"/>
+          </a:xfrm>
+          <a:prstGeom prst="rect">
+            <a:avLst/>
+          </a:prstGeom>
+          <a:noFill/>
+        </p:spPr>
+        <p:txBody>
+          <a:bodyPr wrap="square" tIns="0" bIns="0" lIns="9144" rIns="9144">
+            <a:spAutoFit/>
+          </a:bodyPr>
+          <a:lstStyle/>
+          <a:p>
+            <a:pPr>
+              <a:lnSpc>
+                <a:spcPct val="110000"/>
+              </a:lnSpc>
+              <a:spcBef>
+                <a:spcPts val="0"/>
+              </a:spcBef>
+              <a:spcAft>
+                <a:spcPts val="400"/>
+              </a:spcAft>
+            </a:pPr>
+            <a:r>
+              <a:rPr sz="1600" b="0">
+                <a:solidFill>
+                  <a:srgbClr val="222222"/>
+                </a:solidFill>
+                <a:latin typeface="Noto Sans CJK JP"/>
+                <a:ea typeface="Noto Sans CJK JP"/>
+              </a:rPr>
+              <a:t>学習：16kHz・4秒・batch4 / AdamW lr=0.001 / seed0 / 最大100epoch・patience10</a:t>
             </a:r>
           </a:p>
         </p:txBody>

</xml_diff>